<commit_message>
docs: add Carbon-style code snapshots and Docusaurus logo to decks
- snapshots/: #include usage, make commands, generate_pdf.py (IBM Plex Mono)
- add Docusaurus logo to both presentation cover slides

Co-Authored-By: Claude Opus 4.8 <noreply@anthropic.com>
Claude-Session: https://claude.ai/code/session_01Sme86zd8guaLW1Py5zwzmn
</commit_message>
<xml_diff>
--- a/features-implementees.pptx
+++ b/features-implementees.pptx
@@ -3229,9 +3229,33 @@
           </a:p>
         </p:txBody>
       </p:sp>
-      <p:sp>
-        <p:nvSpPr>
-          <p:cNvPr id="5" name="TextBox 4"/>
+      <p:pic>
+        <p:nvPicPr>
+          <p:cNvPr id="5" name="Picture 4" descr="docusaurus.png"/>
+          <p:cNvPicPr>
+            <a:picLocks noChangeAspect="1"/>
+          </p:cNvPicPr>
+          <p:nvPr/>
+        </p:nvPicPr>
+        <p:blipFill>
+          <a:blip r:embed="rId2"/>
+          <a:stretch>
+            <a:fillRect/>
+          </a:stretch>
+        </p:blipFill>
+        <p:spPr>
+          <a:xfrm>
+            <a:off x="10058400" y="502920"/>
+            <a:ext cx="1005840" cy="1005840"/>
+          </a:xfrm>
+          <a:prstGeom prst="rect">
+            <a:avLst/>
+          </a:prstGeom>
+        </p:spPr>
+      </p:pic>
+      <p:sp>
+        <p:nvSpPr>
+          <p:cNvPr id="6" name="TextBox 5"/>
           <p:cNvSpPr txBox="1"/>
           <p:nvPr/>
         </p:nvSpPr>
@@ -3273,7 +3297,7 @@
       </p:sp>
       <p:sp>
         <p:nvSpPr>
-          <p:cNvPr id="6" name="TextBox 5"/>
+          <p:cNvPr id="7" name="TextBox 6"/>
           <p:cNvSpPr txBox="1"/>
           <p:nvPr/>
         </p:nvSpPr>
@@ -3315,7 +3339,7 @@
       </p:sp>
       <p:sp>
         <p:nvSpPr>
-          <p:cNvPr id="7" name="TextBox 6"/>
+          <p:cNvPr id="8" name="TextBox 7"/>
           <p:cNvSpPr txBox="1"/>
           <p:nvPr/>
         </p:nvSpPr>
@@ -3357,7 +3381,7 @@
       </p:sp>
       <p:sp>
         <p:nvSpPr>
-          <p:cNvPr id="8" name="TextBox 7"/>
+          <p:cNvPr id="9" name="TextBox 8"/>
           <p:cNvSpPr txBox="1"/>
           <p:nvPr/>
         </p:nvSpPr>

</xml_diff>

<commit_message>
docs: reframe decks as usage guide with embedded code snapshots
- both decks restructured as a user guide (no PDF-generation internals)
- embed Carbon-style snapshots: #include usage, make commands, PDF export
- replace generate_pdf.py snapshot with a usage-oriented 'make pdf' one
- add PDF renders of both decks

Co-Authored-By: Claude Opus 4.8 <noreply@anthropic.com>
Claude-Session: https://claude.ai/code/session_01Sme86zd8guaLW1Py5zwzmn
</commit_message>
<xml_diff>
--- a/features-implementees.pptx
+++ b/features-implementees.pptx
@@ -3275,22 +3275,15 @@
           </a:bodyPr>
           <a:lstStyle/>
           <a:p>
-            <a:pPr algn="l">
-              <a:lnSpc>
-                <a:spcPct val="100000"/>
-              </a:lnSpc>
-              <a:spcAft>
-                <a:spcPts val="600"/>
-              </a:spcAft>
-            </a:pPr>
-            <a:r>
-              <a:rPr sz="1600" b="1" i="0">
+            <a:pPr algn="l"/>
+            <a:r>
+              <a:rPr sz="1600" b="1">
                 <a:solidFill>
                   <a:srgbClr val="FFCC00"/>
                 </a:solidFill>
                 <a:latin typeface="Calibri"/>
               </a:rPr>
-              <a:t>PLATEFORME DE DOCUMENTATION TECHNIQUE</a:t>
+              <a:t>GUIDE D'UTILISATION</a:t>
             </a:r>
           </a:p>
         </p:txBody>
@@ -3317,22 +3310,15 @@
           </a:bodyPr>
           <a:lstStyle/>
           <a:p>
-            <a:pPr algn="l">
-              <a:lnSpc>
-                <a:spcPct val="100000"/>
-              </a:lnSpc>
-              <a:spcAft>
-                <a:spcPts val="600"/>
-              </a:spcAft>
-            </a:pPr>
-            <a:r>
-              <a:rPr sz="4400" b="1" i="0">
+            <a:pPr algn="l"/>
+            <a:r>
+              <a:rPr sz="4200" b="1">
                 <a:solidFill>
                   <a:srgbClr val="FFFFFF"/>
                 </a:solidFill>
                 <a:latin typeface="Calibri"/>
               </a:rPr>
-              <a:t>Docusaurus — Features implémentées</a:t>
+              <a:t>Docusaurus — Guide d'utilisation</a:t>
             </a:r>
           </a:p>
         </p:txBody>
@@ -3359,22 +3345,15 @@
           </a:bodyPr>
           <a:lstStyle/>
           <a:p>
-            <a:pPr algn="l">
-              <a:lnSpc>
-                <a:spcPct val="100000"/>
-              </a:lnSpc>
-              <a:spcAft>
-                <a:spcPts val="600"/>
-              </a:spcAft>
-            </a:pPr>
-            <a:r>
-              <a:rPr sz="2000" b="0" i="0">
+            <a:pPr algn="l"/>
+            <a:r>
+              <a:rPr sz="2000" b="0">
                 <a:solidFill>
                   <a:srgbClr val="CCD6EE"/>
                 </a:solidFill>
                 <a:latin typeface="Calibri"/>
               </a:rPr>
-              <a:t>Documentation modulaire, diagrammes d'architecture &amp; export PDF professionnel</a:t>
+              <a:t>Rédiger, prévisualiser, illustrer et exporter votre documentation</a:t>
             </a:r>
           </a:p>
         </p:txBody>
@@ -3401,16 +3380,9 @@
           </a:bodyPr>
           <a:lstStyle/>
           <a:p>
-            <a:pPr algn="l">
-              <a:lnSpc>
-                <a:spcPct val="100000"/>
-              </a:lnSpc>
-              <a:spcAft>
-                <a:spcPts val="600"/>
-              </a:spcAft>
-            </a:pPr>
-            <a:r>
-              <a:rPr sz="1400" b="1" i="0">
+            <a:pPr algn="l"/>
+            <a:r>
+              <a:rPr sz="1400" b="1">
                 <a:solidFill>
                   <a:srgbClr val="AABBDD"/>
                 </a:solidFill>
@@ -3419,7 +3391,7 @@
               <a:t>InnovateIt-ak / docusaurus</a:t>
             </a:r>
             <a:r>
-              <a:rPr sz="1400" b="0" i="0">
+              <a:rPr sz="1400" b="0">
                 <a:solidFill>
                   <a:srgbClr val="AABBDD"/>
                 </a:solidFill>
@@ -3536,16 +3508,40 @@
           </a:p>
         </p:txBody>
       </p:sp>
-      <p:sp>
-        <p:nvSpPr>
-          <p:cNvPr id="4" name="TextBox 3"/>
+      <p:pic>
+        <p:nvPicPr>
+          <p:cNvPr id="4" name="Picture 3" descr="docusaurus.png"/>
+          <p:cNvPicPr>
+            <a:picLocks noChangeAspect="1"/>
+          </p:cNvPicPr>
+          <p:nvPr/>
+        </p:nvPicPr>
+        <p:blipFill>
+          <a:blip r:embed="rId2"/>
+          <a:stretch>
+            <a:fillRect/>
+          </a:stretch>
+        </p:blipFill>
+        <p:spPr>
+          <a:xfrm>
+            <a:off x="10424160" y="457200"/>
+            <a:ext cx="822960" cy="822960"/>
+          </a:xfrm>
+          <a:prstGeom prst="rect">
+            <a:avLst/>
+          </a:prstGeom>
+        </p:spPr>
+      </p:pic>
+      <p:sp>
+        <p:nvSpPr>
+          <p:cNvPr id="5" name="TextBox 4"/>
           <p:cNvSpPr txBox="1"/>
           <p:nvPr/>
         </p:nvSpPr>
         <p:spPr>
           <a:xfrm>
             <a:off x="914400" y="640080"/>
-            <a:ext cx="10058400" cy="731520"/>
+            <a:ext cx="9144000" cy="731520"/>
           </a:xfrm>
           <a:prstGeom prst="rect">
             <a:avLst/>
@@ -3558,29 +3554,22 @@
           </a:bodyPr>
           <a:lstStyle/>
           <a:p>
-            <a:pPr algn="l">
-              <a:lnSpc>
-                <a:spcPct val="100000"/>
-              </a:lnSpc>
-              <a:spcAft>
-                <a:spcPts val="600"/>
-              </a:spcAft>
-            </a:pPr>
-            <a:r>
-              <a:rPr sz="3400" b="1" i="0">
+            <a:pPr algn="l"/>
+            <a:r>
+              <a:rPr sz="3200" b="1">
                 <a:solidFill>
                   <a:srgbClr val="FFFFFF"/>
                 </a:solidFill>
                 <a:latin typeface="Calibri"/>
               </a:rPr>
-              <a:t>En résumé</a:t>
-            </a:r>
-          </a:p>
-        </p:txBody>
-      </p:sp>
-      <p:sp>
-        <p:nvSpPr>
-          <p:cNvPr id="5" name="Rectangle 4"/>
+              <a:t>Aide-mémoire</a:t>
+            </a:r>
+          </a:p>
+        </p:txBody>
+      </p:sp>
+      <p:sp>
+        <p:nvSpPr>
+          <p:cNvPr id="6" name="Rectangle 5"/>
           <p:cNvSpPr/>
           <p:nvPr/>
         </p:nvSpPr>
@@ -3624,13 +3613,13 @@
       </p:sp>
       <p:sp>
         <p:nvSpPr>
-          <p:cNvPr id="6" name="TextBox 5"/>
+          <p:cNvPr id="7" name="TextBox 6"/>
           <p:cNvSpPr txBox="1"/>
           <p:nvPr/>
         </p:nvSpPr>
         <p:spPr>
           <a:xfrm>
-            <a:off x="1005840" y="1737360"/>
+            <a:off x="1005840" y="1783080"/>
             <a:ext cx="10241280" cy="640080"/>
           </a:xfrm>
           <a:prstGeom prst="rect">
@@ -3644,16 +3633,9 @@
           </a:bodyPr>
           <a:lstStyle/>
           <a:p>
-            <a:pPr algn="l">
-              <a:lnSpc>
-                <a:spcPct val="100000"/>
-              </a:lnSpc>
-              <a:spcAft>
-                <a:spcPts val="600"/>
-              </a:spcAft>
-            </a:pPr>
-            <a:r>
-              <a:rPr sz="1800" b="1" i="0">
+            <a:pPr algn="l"/>
+            <a:r>
+              <a:rPr sz="1700" b="1">
                 <a:solidFill>
                   <a:srgbClr val="FFCC00"/>
                 </a:solidFill>
@@ -3662,35 +3644,35 @@
               <a:t>✓  </a:t>
             </a:r>
             <a:r>
-              <a:rPr sz="1800" b="1" i="0">
+              <a:rPr sz="1700" b="1">
                 <a:solidFill>
                   <a:srgbClr val="FFFFFF"/>
                 </a:solidFill>
                 <a:latin typeface="Calibri"/>
               </a:rPr>
-              <a:t>Documentation modulaire  —  </a:t>
-            </a:r>
-            <a:r>
-              <a:rPr sz="1600" b="0" i="0">
+              <a:t>make dev  —  </a:t>
+            </a:r>
+            <a:r>
+              <a:rPr sz="1500" b="0">
                 <a:solidFill>
                   <a:srgbClr val="CCD6EE"/>
                 </a:solidFill>
                 <a:latin typeface="Calibri"/>
               </a:rPr>
-              <a:t>Directive #include + hot reload des fragments</a:t>
-            </a:r>
-          </a:p>
-        </p:txBody>
-      </p:sp>
-      <p:sp>
-        <p:nvSpPr>
-          <p:cNvPr id="7" name="TextBox 6"/>
+              <a:t>lancer le serveur local (aperçu en direct)</a:t>
+            </a:r>
+          </a:p>
+        </p:txBody>
+      </p:sp>
+      <p:sp>
+        <p:nvSpPr>
+          <p:cNvPr id="8" name="TextBox 7"/>
           <p:cNvSpPr txBox="1"/>
           <p:nvPr/>
         </p:nvSpPr>
         <p:spPr>
           <a:xfrm>
-            <a:off x="1005840" y="2395728"/>
+            <a:off x="1005840" y="2404872"/>
             <a:ext cx="10241280" cy="640080"/>
           </a:xfrm>
           <a:prstGeom prst="rect">
@@ -3704,16 +3686,9 @@
           </a:bodyPr>
           <a:lstStyle/>
           <a:p>
-            <a:pPr algn="l">
-              <a:lnSpc>
-                <a:spcPct val="100000"/>
-              </a:lnSpc>
-              <a:spcAft>
-                <a:spcPts val="600"/>
-              </a:spcAft>
-            </a:pPr>
-            <a:r>
-              <a:rPr sz="1800" b="1" i="0">
+            <a:pPr algn="l"/>
+            <a:r>
+              <a:rPr sz="1700" b="1">
                 <a:solidFill>
                   <a:srgbClr val="FFCC00"/>
                 </a:solidFill>
@@ -3722,35 +3697,35 @@
               <a:t>✓  </a:t>
             </a:r>
             <a:r>
-              <a:rPr sz="1800" b="1" i="0">
+              <a:rPr sz="1700" b="1">
                 <a:solidFill>
                   <a:srgbClr val="FFFFFF"/>
                 </a:solidFill>
                 <a:latin typeface="Calibri"/>
               </a:rPr>
-              <a:t>Réutilisation  —  </a:t>
-            </a:r>
-            <a:r>
-              <a:rPr sz="1600" b="0" i="0">
+              <a:t>#include "fichier.md"  —  </a:t>
+            </a:r>
+            <a:r>
+              <a:rPr sz="1500" b="0">
                 <a:solidFill>
                   <a:srgbClr val="CCD6EE"/>
                 </a:solidFill>
                 <a:latin typeface="Calibri"/>
               </a:rPr>
-              <a:t>Partials &amp; composant MDX global « Prérequis »</a:t>
-            </a:r>
-          </a:p>
-        </p:txBody>
-      </p:sp>
-      <p:sp>
-        <p:nvSpPr>
-          <p:cNvPr id="8" name="TextBox 7"/>
+              <a:t>assembler des fragments réutilisables</a:t>
+            </a:r>
+          </a:p>
+        </p:txBody>
+      </p:sp>
+      <p:sp>
+        <p:nvSpPr>
+          <p:cNvPr id="9" name="TextBox 8"/>
           <p:cNvSpPr txBox="1"/>
           <p:nvPr/>
         </p:nvSpPr>
         <p:spPr>
           <a:xfrm>
-            <a:off x="1005840" y="3054096"/>
+            <a:off x="1005840" y="3026664"/>
             <a:ext cx="10241280" cy="640080"/>
           </a:xfrm>
           <a:prstGeom prst="rect">
@@ -3764,16 +3739,9 @@
           </a:bodyPr>
           <a:lstStyle/>
           <a:p>
-            <a:pPr algn="l">
-              <a:lnSpc>
-                <a:spcPct val="100000"/>
-              </a:lnSpc>
-              <a:spcAft>
-                <a:spcPts val="600"/>
-              </a:spcAft>
-            </a:pPr>
-            <a:r>
-              <a:rPr sz="1800" b="1" i="0">
+            <a:pPr algn="l"/>
+            <a:r>
+              <a:rPr sz="1700" b="1">
                 <a:solidFill>
                   <a:srgbClr val="FFCC00"/>
                 </a:solidFill>
@@ -3782,35 +3750,35 @@
               <a:t>✓  </a:t>
             </a:r>
             <a:r>
-              <a:rPr sz="1800" b="1" i="0">
+              <a:rPr sz="1700" b="1">
                 <a:solidFill>
                   <a:srgbClr val="FFFFFF"/>
                 </a:solidFill>
                 <a:latin typeface="Calibri"/>
               </a:rPr>
-              <a:t>Architecture as code  —  </a:t>
-            </a:r>
-            <a:r>
-              <a:rPr sz="1600" b="0" i="0">
+              <a:t>« Prérequis »  —  </a:t>
+            </a:r>
+            <a:r>
+              <a:rPr sz="1500" b="0">
                 <a:solidFill>
                   <a:srgbClr val="CCD6EE"/>
                 </a:solidFill>
                 <a:latin typeface="Calibri"/>
               </a:rPr>
-              <a:t>LikeC4 (C4) + tldraw, diagrammes interactifs</a:t>
-            </a:r>
-          </a:p>
-        </p:txBody>
-      </p:sp>
-      <p:sp>
-        <p:nvSpPr>
-          <p:cNvPr id="9" name="TextBox 8"/>
+              <a:t>réutiliser un bloc partout, une seule source</a:t>
+            </a:r>
+          </a:p>
+        </p:txBody>
+      </p:sp>
+      <p:sp>
+        <p:nvSpPr>
+          <p:cNvPr id="10" name="TextBox 9"/>
           <p:cNvSpPr txBox="1"/>
           <p:nvPr/>
         </p:nvSpPr>
         <p:spPr>
           <a:xfrm>
-            <a:off x="1005840" y="3712464"/>
+            <a:off x="1005840" y="3648456"/>
             <a:ext cx="10241280" cy="640080"/>
           </a:xfrm>
           <a:prstGeom prst="rect">
@@ -3824,16 +3792,9 @@
           </a:bodyPr>
           <a:lstStyle/>
           <a:p>
-            <a:pPr algn="l">
-              <a:lnSpc>
-                <a:spcPct val="100000"/>
-              </a:lnSpc>
-              <a:spcAft>
-                <a:spcPts val="600"/>
-              </a:spcAft>
-            </a:pPr>
-            <a:r>
-              <a:rPr sz="1800" b="1" i="0">
+            <a:pPr algn="l"/>
+            <a:r>
+              <a:rPr sz="1700" b="1">
                 <a:solidFill>
                   <a:srgbClr val="FFCC00"/>
                 </a:solidFill>
@@ -3842,35 +3803,35 @@
               <a:t>✓  </a:t>
             </a:r>
             <a:r>
-              <a:rPr sz="1800" b="1" i="0">
+              <a:rPr sz="1700" b="1">
                 <a:solidFill>
                   <a:srgbClr val="FFFFFF"/>
                 </a:solidFill>
                 <a:latin typeface="Calibri"/>
               </a:rPr>
-              <a:t>Export PDF pro  —  </a:t>
-            </a:r>
-            <a:r>
-              <a:rPr sz="1600" b="0" i="0">
+              <a:t>LikeC4 / tldraw  —  </a:t>
+            </a:r>
+            <a:r>
+              <a:rPr sz="1500" b="0">
                 <a:solidFill>
                   <a:srgbClr val="CCD6EE"/>
                 </a:solidFill>
                 <a:latin typeface="Calibri"/>
               </a:rPr>
-              <a:t>WeasyPrint conteneurisé, couverture + TOC + signets</a:t>
-            </a:r>
-          </a:p>
-        </p:txBody>
-      </p:sp>
-      <p:sp>
-        <p:nvSpPr>
-          <p:cNvPr id="10" name="TextBox 9"/>
+              <a:t>consulter les diagrammes d'architecture</a:t>
+            </a:r>
+          </a:p>
+        </p:txBody>
+      </p:sp>
+      <p:sp>
+        <p:nvSpPr>
+          <p:cNvPr id="11" name="TextBox 10"/>
           <p:cNvSpPr txBox="1"/>
           <p:nvPr/>
         </p:nvSpPr>
         <p:spPr>
           <a:xfrm>
-            <a:off x="1005840" y="4370832"/>
+            <a:off x="1005840" y="4270248"/>
             <a:ext cx="10241280" cy="640080"/>
           </a:xfrm>
           <a:prstGeom prst="rect">
@@ -3884,16 +3845,9 @@
           </a:bodyPr>
           <a:lstStyle/>
           <a:p>
-            <a:pPr algn="l">
-              <a:lnSpc>
-                <a:spcPct val="100000"/>
-              </a:lnSpc>
-              <a:spcAft>
-                <a:spcPts val="600"/>
-              </a:spcAft>
-            </a:pPr>
-            <a:r>
-              <a:rPr sz="1800" b="1" i="0">
+            <a:pPr algn="l"/>
+            <a:r>
+              <a:rPr sz="1700" b="1">
                 <a:solidFill>
                   <a:srgbClr val="FFCC00"/>
                 </a:solidFill>
@@ -3902,35 +3856,35 @@
               <a:t>✓  </a:t>
             </a:r>
             <a:r>
-              <a:rPr sz="1800" b="1" i="0">
+              <a:rPr sz="1700" b="1">
                 <a:solidFill>
                   <a:srgbClr val="FFFFFF"/>
                 </a:solidFill>
                 <a:latin typeface="Calibri"/>
               </a:rPr>
-              <a:t>Sécurité  —  </a:t>
-            </a:r>
-            <a:r>
-              <a:rPr sz="1600" b="0" i="0">
+              <a:t>make pdf  —  </a:t>
+            </a:r>
+            <a:r>
+              <a:rPr sz="1500" b="0">
                 <a:solidFill>
                   <a:srgbClr val="CCD6EE"/>
                 </a:solidFill>
                 <a:latin typeface="Calibri"/>
               </a:rPr>
-              <a:t>Image Red Hat hardened, build multi-stage, deps à jour</a:t>
-            </a:r>
-          </a:p>
-        </p:txBody>
-      </p:sp>
-      <p:sp>
-        <p:nvSpPr>
-          <p:cNvPr id="11" name="TextBox 10"/>
+              <a:t>exporter toute la doc en un PDF brandé</a:t>
+            </a:r>
+          </a:p>
+        </p:txBody>
+      </p:sp>
+      <p:sp>
+        <p:nvSpPr>
+          <p:cNvPr id="12" name="TextBox 11"/>
           <p:cNvSpPr txBox="1"/>
           <p:nvPr/>
         </p:nvSpPr>
         <p:spPr>
           <a:xfrm>
-            <a:off x="1005840" y="5029200"/>
+            <a:off x="1005840" y="4892040"/>
             <a:ext cx="10241280" cy="640080"/>
           </a:xfrm>
           <a:prstGeom prst="rect">
@@ -3944,16 +3898,9 @@
           </a:bodyPr>
           <a:lstStyle/>
           <a:p>
-            <a:pPr algn="l">
-              <a:lnSpc>
-                <a:spcPct val="100000"/>
-              </a:lnSpc>
-              <a:spcAft>
-                <a:spcPts val="600"/>
-              </a:spcAft>
-            </a:pPr>
-            <a:r>
-              <a:rPr sz="1800" b="1" i="0">
+            <a:pPr algn="l"/>
+            <a:r>
+              <a:rPr sz="1700" b="1">
                 <a:solidFill>
                   <a:srgbClr val="FFCC00"/>
                 </a:solidFill>
@@ -3962,35 +3909,35 @@
               <a:t>✓  </a:t>
             </a:r>
             <a:r>
-              <a:rPr sz="1800" b="1" i="0">
+              <a:rPr sz="1700" b="1">
                 <a:solidFill>
                   <a:srgbClr val="FFFFFF"/>
                 </a:solidFill>
                 <a:latin typeface="Calibri"/>
               </a:rPr>
-              <a:t>CI/CD  —  </a:t>
-            </a:r>
-            <a:r>
-              <a:rPr sz="1600" b="0" i="0">
+              <a:t>git push  —  </a:t>
+            </a:r>
+            <a:r>
+              <a:rPr sz="1500" b="0">
                 <a:solidFill>
                   <a:srgbClr val="CCD6EE"/>
                 </a:solidFill>
                 <a:latin typeface="Calibri"/>
               </a:rPr>
-              <a:t>GitHub Pages, artefacts PDF, PDF de release en PR</a:t>
-            </a:r>
-          </a:p>
-        </p:txBody>
-      </p:sp>
-      <p:sp>
-        <p:nvSpPr>
-          <p:cNvPr id="12" name="TextBox 11"/>
+              <a:t>site + PDF publiés automatiquement (CI/CD)</a:t>
+            </a:r>
+          </a:p>
+        </p:txBody>
+      </p:sp>
+      <p:sp>
+        <p:nvSpPr>
+          <p:cNvPr id="13" name="TextBox 12"/>
           <p:cNvSpPr txBox="1"/>
           <p:nvPr/>
         </p:nvSpPr>
         <p:spPr>
           <a:xfrm>
-            <a:off x="914400" y="6126480"/>
+            <a:off x="914400" y="6217920"/>
             <a:ext cx="10058400" cy="457200"/>
           </a:xfrm>
           <a:prstGeom prst="rect">
@@ -4004,22 +3951,15 @@
           </a:bodyPr>
           <a:lstStyle/>
           <a:p>
-            <a:pPr algn="l">
-              <a:lnSpc>
-                <a:spcPct val="100000"/>
-              </a:lnSpc>
-              <a:spcAft>
-                <a:spcPts val="600"/>
-              </a:spcAft>
-            </a:pPr>
-            <a:r>
-              <a:rPr sz="1400" b="1" i="0">
+            <a:pPr algn="l"/>
+            <a:r>
+              <a:rPr sz="1400" b="1">
                 <a:solidFill>
                   <a:srgbClr val="FFCC00"/>
                 </a:solidFill>
                 <a:latin typeface="Calibri"/>
               </a:rPr>
-              <a:t>Merci !  —  InnovateIt-ak / docusaurus</a:t>
+              <a:t>Bonne rédaction !  —  InnovateIt-ak / docusaurus</a:t>
             </a:r>
           </a:p>
         </p:txBody>
@@ -4108,16 +4048,9 @@
           </a:bodyPr>
           <a:lstStyle/>
           <a:p>
-            <a:pPr algn="l">
-              <a:lnSpc>
-                <a:spcPct val="100000"/>
-              </a:lnSpc>
-              <a:spcAft>
-                <a:spcPts val="600"/>
-              </a:spcAft>
-            </a:pPr>
-            <a:r>
-              <a:rPr sz="1300" b="1" i="0">
+            <a:pPr algn="l"/>
+            <a:r>
+              <a:rPr sz="1300" b="1">
                 <a:solidFill>
                   <a:srgbClr val="1B4FA0"/>
                 </a:solidFill>
@@ -4150,22 +4083,15 @@
           </a:bodyPr>
           <a:lstStyle/>
           <a:p>
-            <a:pPr algn="l">
-              <a:lnSpc>
-                <a:spcPct val="100000"/>
-              </a:lnSpc>
-              <a:spcAft>
-                <a:spcPts val="600"/>
-              </a:spcAft>
-            </a:pPr>
-            <a:r>
-              <a:rPr sz="3000" b="1" i="0">
+            <a:pPr algn="l"/>
+            <a:r>
+              <a:rPr sz="2800" b="1">
                 <a:solidFill>
                   <a:srgbClr val="003399"/>
                 </a:solidFill>
                 <a:latin typeface="Calibri"/>
               </a:rPr>
-              <a:t>Vue d'ensemble</a:t>
+              <a:t>Ce que vous pouvez faire</a:t>
             </a:r>
           </a:p>
         </p:txBody>
@@ -4178,7 +4104,7 @@
         </p:nvSpPr>
         <p:spPr>
           <a:xfrm>
-            <a:off x="658368" y="1554480"/>
+            <a:off x="658368" y="1481328"/>
             <a:ext cx="2011680" cy="38100"/>
           </a:xfrm>
           <a:prstGeom prst="rect">
@@ -4222,8 +4148,8 @@
         </p:nvSpPr>
         <p:spPr>
           <a:xfrm>
-            <a:off x="658368" y="1920240"/>
-            <a:ext cx="10881360" cy="4297680"/>
+            <a:off x="658368" y="1828800"/>
+            <a:ext cx="10881360" cy="4389120"/>
           </a:xfrm>
           <a:prstGeom prst="rect">
             <a:avLst/>
@@ -4238,14 +4164,14 @@
           <a:p>
             <a:pPr>
               <a:lnSpc>
-                <a:spcPct val="105000"/>
+                <a:spcPct val="104000"/>
               </a:lnSpc>
               <a:spcAft>
-                <a:spcPts val="1000"/>
+                <a:spcPts val="900"/>
               </a:spcAft>
             </a:pPr>
             <a:r>
-              <a:rPr sz="1700" b="1">
+              <a:rPr sz="1600" b="1">
                 <a:solidFill>
                   <a:srgbClr val="FFCC00"/>
                 </a:solidFill>
@@ -4253,33 +4179,33 @@
               <a:t>•  </a:t>
             </a:r>
             <a:r>
-              <a:rPr sz="1700" b="1">
+              <a:rPr sz="1600" b="1">
                 <a:solidFill>
                   <a:srgbClr val="003399"/>
                 </a:solidFill>
               </a:rPr>
-              <a:t>Objectif — </a:t>
-            </a:r>
-            <a:r>
-              <a:rPr sz="1700">
+              <a:t>Rédiger — </a:t>
+            </a:r>
+            <a:r>
+              <a:rPr sz="1600">
                 <a:solidFill>
                   <a:srgbClr val="1A1A2E"/>
                 </a:solidFill>
               </a:rPr>
-              <a:t>transformer Docusaurus en plateforme de documentation technique d'architecture, versionnée et exportable.</a:t>
+              <a:t>écrivez vos docs en Markdown / MDX, comme d'habitude.</a:t>
             </a:r>
           </a:p>
           <a:p>
             <a:pPr>
               <a:lnSpc>
-                <a:spcPct val="105000"/>
+                <a:spcPct val="104000"/>
               </a:lnSpc>
               <a:spcAft>
-                <a:spcPts val="1000"/>
+                <a:spcPts val="900"/>
               </a:spcAft>
             </a:pPr>
             <a:r>
-              <a:rPr sz="1700" b="1">
+              <a:rPr sz="1600" b="1">
                 <a:solidFill>
                   <a:srgbClr val="FFCC00"/>
                 </a:solidFill>
@@ -4287,33 +4213,33 @@
               <a:t>•  </a:t>
             </a:r>
             <a:r>
-              <a:rPr sz="1700" b="1">
+              <a:rPr sz="1600" b="1">
                 <a:solidFill>
                   <a:srgbClr val="003399"/>
                 </a:solidFill>
               </a:rPr>
-              <a:t>Documentation modulaire — </a:t>
-            </a:r>
-            <a:r>
-              <a:rPr sz="1700">
+              <a:t>Assembler — </a:t>
+            </a:r>
+            <a:r>
+              <a:rPr sz="1600">
                 <a:solidFill>
                   <a:srgbClr val="1A1A2E"/>
                 </a:solidFill>
               </a:rPr>
-              <a:t>directive #include pour assembler des fragments Markdown réutilisables.</a:t>
+              <a:t>réutilisez des fragments avec la directive #include — sans aucun import.</a:t>
             </a:r>
           </a:p>
           <a:p>
             <a:pPr>
               <a:lnSpc>
-                <a:spcPct val="105000"/>
+                <a:spcPct val="104000"/>
               </a:lnSpc>
               <a:spcAft>
-                <a:spcPts val="1000"/>
+                <a:spcPts val="900"/>
               </a:spcAft>
             </a:pPr>
             <a:r>
-              <a:rPr sz="1700" b="1">
+              <a:rPr sz="1600" b="1">
                 <a:solidFill>
                   <a:srgbClr val="FFCC00"/>
                 </a:solidFill>
@@ -4321,33 +4247,33 @@
               <a:t>•  </a:t>
             </a:r>
             <a:r>
-              <a:rPr sz="1700" b="1">
+              <a:rPr sz="1600" b="1">
                 <a:solidFill>
                   <a:srgbClr val="003399"/>
                 </a:solidFill>
               </a:rPr>
-              <a:t>Diagrammes vivants — </a:t>
-            </a:r>
-            <a:r>
-              <a:rPr sz="1700">
+              <a:t>Illustrer — </a:t>
+            </a:r>
+            <a:r>
+              <a:rPr sz="1600">
                 <a:solidFill>
                   <a:srgbClr val="1A1A2E"/>
                 </a:solidFill>
               </a:rPr>
-              <a:t>intégration LikeC4 (architecture as code) et tldraw pour les schémas interactifs.</a:t>
+              <a:t>intégrez des diagrammes d'architecture (LikeC4) et des schémas (tldraw).</a:t>
             </a:r>
           </a:p>
           <a:p>
             <a:pPr>
               <a:lnSpc>
-                <a:spcPct val="105000"/>
+                <a:spcPct val="104000"/>
               </a:lnSpc>
               <a:spcAft>
-                <a:spcPts val="1000"/>
+                <a:spcPts val="900"/>
               </a:spcAft>
             </a:pPr>
             <a:r>
-              <a:rPr sz="1700" b="1">
+              <a:rPr sz="1600" b="1">
                 <a:solidFill>
                   <a:srgbClr val="FFCC00"/>
                 </a:solidFill>
@@ -4355,33 +4281,33 @@
               <a:t>•  </a:t>
             </a:r>
             <a:r>
-              <a:rPr sz="1700" b="1">
+              <a:rPr sz="1600" b="1">
                 <a:solidFill>
                   <a:srgbClr val="003399"/>
                 </a:solidFill>
               </a:rPr>
-              <a:t>Export PDF pro — </a:t>
-            </a:r>
-            <a:r>
-              <a:rPr sz="1700">
+              <a:t>Prévisualiser — </a:t>
+            </a:r>
+            <a:r>
+              <a:rPr sz="1600">
                 <a:solidFill>
                   <a:srgbClr val="1A1A2E"/>
                 </a:solidFill>
               </a:rPr>
-              <a:t>génération d'un PDF unique, paginé et branché, via WeasyPrint conteneurisé.</a:t>
+              <a:t>aperçu en direct : toute modif (même d'un fragment inclus) se rafraîchit instantanément.</a:t>
             </a:r>
           </a:p>
           <a:p>
             <a:pPr>
               <a:lnSpc>
-                <a:spcPct val="105000"/>
+                <a:spcPct val="104000"/>
               </a:lnSpc>
               <a:spcAft>
-                <a:spcPts val="1000"/>
+                <a:spcPts val="900"/>
               </a:spcAft>
             </a:pPr>
             <a:r>
-              <a:rPr sz="1700" b="1">
+              <a:rPr sz="1600" b="1">
                 <a:solidFill>
                   <a:srgbClr val="FFCC00"/>
                 </a:solidFill>
@@ -4389,20 +4315,20 @@
               <a:t>•  </a:t>
             </a:r>
             <a:r>
-              <a:rPr sz="1700" b="1">
+              <a:rPr sz="1600" b="1">
                 <a:solidFill>
                   <a:srgbClr val="003399"/>
                 </a:solidFill>
               </a:rPr>
-              <a:t>Industrialisation — </a:t>
-            </a:r>
-            <a:r>
-              <a:rPr sz="1700">
+              <a:t>Exporter — </a:t>
+            </a:r>
+            <a:r>
+              <a:rPr sz="1600">
                 <a:solidFill>
                   <a:srgbClr val="1A1A2E"/>
                 </a:solidFill>
               </a:rPr>
-              <a:t>Docker / docker-compose, Makefile et CI/CD GitHub Actions (Pages + artefacts PDF).</a:t>
+              <a:t>générez un PDF unique et brandé, et publiez le site en une commande.</a:t>
             </a:r>
           </a:p>
         </p:txBody>
@@ -4415,7 +4341,7 @@
         </p:nvSpPr>
         <p:spPr>
           <a:xfrm>
-            <a:off x="640080" y="6400800"/>
+            <a:off x="640080" y="6419088"/>
             <a:ext cx="9144000" cy="320040"/>
           </a:xfrm>
           <a:prstGeom prst="rect">
@@ -4429,22 +4355,15 @@
           </a:bodyPr>
           <a:lstStyle/>
           <a:p>
-            <a:pPr algn="l">
-              <a:lnSpc>
-                <a:spcPct val="100000"/>
-              </a:lnSpc>
-              <a:spcAft>
-                <a:spcPts val="600"/>
-              </a:spcAft>
-            </a:pPr>
-            <a:r>
-              <a:rPr sz="900" b="0" i="0">
+            <a:pPr algn="l"/>
+            <a:r>
+              <a:rPr sz="900" b="0">
                 <a:solidFill>
                   <a:srgbClr val="4A4A4A"/>
                 </a:solidFill>
                 <a:latin typeface="Calibri"/>
               </a:rPr>
-              <a:t>Plateforme de documentation Docusaurus — features implémentées</a:t>
+              <a:t>Docusaurus — guide d'utilisation</a:t>
             </a:r>
           </a:p>
         </p:txBody>
@@ -4457,7 +4376,7 @@
         </p:nvSpPr>
         <p:spPr>
           <a:xfrm>
-            <a:off x="11247120" y="6400800"/>
+            <a:off x="11247120" y="6419088"/>
             <a:ext cx="731520" cy="320040"/>
           </a:xfrm>
           <a:prstGeom prst="rect">
@@ -4471,16 +4390,9 @@
           </a:bodyPr>
           <a:lstStyle/>
           <a:p>
-            <a:pPr algn="r">
-              <a:lnSpc>
-                <a:spcPct val="100000"/>
-              </a:lnSpc>
-              <a:spcAft>
-                <a:spcPts val="600"/>
-              </a:spcAft>
-            </a:pPr>
-            <a:r>
-              <a:rPr sz="900" b="1" i="0">
+            <a:pPr algn="r"/>
+            <a:r>
+              <a:rPr sz="900" b="1">
                 <a:solidFill>
                   <a:srgbClr val="4A4A4A"/>
                 </a:solidFill>
@@ -4575,22 +4487,15 @@
           </a:bodyPr>
           <a:lstStyle/>
           <a:p>
-            <a:pPr algn="l">
-              <a:lnSpc>
-                <a:spcPct val="100000"/>
-              </a:lnSpc>
-              <a:spcAft>
-                <a:spcPts val="600"/>
-              </a:spcAft>
-            </a:pPr>
-            <a:r>
-              <a:rPr sz="1300" b="1" i="0">
+            <a:pPr algn="l"/>
+            <a:r>
+              <a:rPr sz="1300" b="1">
                 <a:solidFill>
                   <a:srgbClr val="1B4FA0"/>
                 </a:solidFill>
                 <a:latin typeface="Calibri"/>
               </a:rPr>
-              <a:t>FEATURE 1 — DOCUMENTATION MODULAIRE</a:t>
+              <a:t>RÉDIGER — DOCUMENTATION MODULAIRE</a:t>
             </a:r>
           </a:p>
         </p:txBody>
@@ -4617,22 +4522,15 @@
           </a:bodyPr>
           <a:lstStyle/>
           <a:p>
-            <a:pPr algn="l">
-              <a:lnSpc>
-                <a:spcPct val="100000"/>
-              </a:lnSpc>
-              <a:spcAft>
-                <a:spcPts val="600"/>
-              </a:spcAft>
-            </a:pPr>
-            <a:r>
-              <a:rPr sz="3000" b="1" i="0">
+            <a:pPr algn="l"/>
+            <a:r>
+              <a:rPr sz="2800" b="1">
                 <a:solidFill>
                   <a:srgbClr val="003399"/>
                 </a:solidFill>
                 <a:latin typeface="Calibri"/>
               </a:rPr>
-              <a:t>Directive #include</a:t>
+              <a:t>Assembler avec #include</a:t>
             </a:r>
           </a:p>
         </p:txBody>
@@ -4645,7 +4543,7 @@
         </p:nvSpPr>
         <p:spPr>
           <a:xfrm>
-            <a:off x="658368" y="1554480"/>
+            <a:off x="658368" y="1481328"/>
             <a:ext cx="2011680" cy="38100"/>
           </a:xfrm>
           <a:prstGeom prst="rect">
@@ -4689,8 +4587,8 @@
         </p:nvSpPr>
         <p:spPr>
           <a:xfrm>
-            <a:off x="658368" y="1920240"/>
-            <a:ext cx="10881360" cy="4297680"/>
+            <a:off x="658368" y="1828800"/>
+            <a:ext cx="5029200" cy="4389120"/>
           </a:xfrm>
           <a:prstGeom prst="rect">
             <a:avLst/>
@@ -4705,14 +4603,14 @@
           <a:p>
             <a:pPr>
               <a:lnSpc>
-                <a:spcPct val="105000"/>
+                <a:spcPct val="104000"/>
               </a:lnSpc>
               <a:spcAft>
-                <a:spcPts val="1000"/>
+                <a:spcPts val="900"/>
               </a:spcAft>
             </a:pPr>
             <a:r>
-              <a:rPr sz="1700" b="1">
+              <a:rPr sz="1600" b="1">
                 <a:solidFill>
                   <a:srgbClr val="FFCC00"/>
                 </a:solidFill>
@@ -4720,103 +4618,111 @@
               <a:t>•  </a:t>
             </a:r>
             <a:r>
-              <a:rPr sz="1700">
+              <a:rPr sz="1600" b="1">
+                <a:solidFill>
+                  <a:srgbClr val="003399"/>
+                </a:solidFill>
+              </a:rPr>
+              <a:t>But — </a:t>
+            </a:r>
+            <a:r>
+              <a:rPr sz="1600">
                 <a:solidFill>
                   <a:srgbClr val="1A1A2E"/>
                 </a:solidFill>
               </a:rPr>
-              <a:t>Plugin remark maison : assemble plusieurs fichiers Markdown en une seule page.</a:t>
+              <a:t>composer une page à partir de plusieurs fichiers.</a:t>
             </a:r>
           </a:p>
           <a:p>
             <a:pPr>
               <a:lnSpc>
-                <a:spcPct val="105000"/>
+                <a:spcPct val="104000"/>
               </a:lnSpc>
               <a:spcAft>
-                <a:spcPts val="1000"/>
+                <a:spcPts val="900"/>
               </a:spcAft>
             </a:pPr>
             <a:r>
-              <a:rPr sz="1500" b="1">
-                <a:solidFill>
-                  <a:srgbClr val="1B4FA0"/>
-                </a:solidFill>
-              </a:rPr>
-              <a:t>    –  </a:t>
-            </a:r>
-            <a:r>
-              <a:rPr sz="1500">
-                <a:solidFill>
-                  <a:srgbClr val="4A4A4A"/>
-                </a:solidFill>
-              </a:rPr>
-              <a:t>syntaxe simple : #include "chemin/vers/fragment.md" sur sa propre ligne.</a:t>
+              <a:rPr sz="1600" b="1">
+                <a:solidFill>
+                  <a:srgbClr val="FFCC00"/>
+                </a:solidFill>
+              </a:rPr>
+              <a:t>•  </a:t>
+            </a:r>
+            <a:r>
+              <a:rPr sz="1600">
+                <a:solidFill>
+                  <a:srgbClr val="1A1A2E"/>
+                </a:solidFill>
+              </a:rPr>
+              <a:t>écrivez #include "chemin/fichier.md" sur sa propre ligne.</a:t>
             </a:r>
           </a:p>
           <a:p>
             <a:pPr>
               <a:lnSpc>
-                <a:spcPct val="105000"/>
+                <a:spcPct val="104000"/>
               </a:lnSpc>
               <a:spcAft>
-                <a:spcPts val="1000"/>
+                <a:spcPts val="900"/>
               </a:spcAft>
             </a:pPr>
             <a:r>
-              <a:rPr sz="1500" b="1">
+              <a:rPr sz="1400" b="1">
                 <a:solidFill>
                   <a:srgbClr val="1B4FA0"/>
                 </a:solidFill>
               </a:rPr>
-              <a:t>    –  </a:t>
-            </a:r>
-            <a:r>
-              <a:rPr sz="1500">
+              <a:t>   –  </a:t>
+            </a:r>
+            <a:r>
+              <a:rPr sz="1400">
                 <a:solidFill>
                   <a:srgbClr val="4A4A4A"/>
                 </a:solidFill>
               </a:rPr>
-              <a:t>aucun import / déclaration : le contenu est inséré à l'emplacement de la directive.</a:t>
+              <a:t>aucun import : le contenu est inséré à cet endroit.</a:t>
             </a:r>
           </a:p>
           <a:p>
             <a:pPr>
               <a:lnSpc>
-                <a:spcPct val="105000"/>
+                <a:spcPct val="104000"/>
               </a:lnSpc>
               <a:spcAft>
-                <a:spcPts val="1000"/>
+                <a:spcPts val="900"/>
               </a:spcAft>
             </a:pPr>
             <a:r>
-              <a:rPr sz="1500" b="1">
+              <a:rPr sz="1400" b="1">
                 <a:solidFill>
                   <a:srgbClr val="1B4FA0"/>
                 </a:solidFill>
               </a:rPr>
-              <a:t>    –  </a:t>
-            </a:r>
-            <a:r>
-              <a:rPr sz="1500">
+              <a:t>   –  </a:t>
+            </a:r>
+            <a:r>
+              <a:rPr sz="1400">
                 <a:solidFill>
                   <a:srgbClr val="4A4A4A"/>
                 </a:solidFill>
               </a:rPr>
-              <a:t>chemin résolu relativement au fichier appelant, front-matter retiré automatiquement.</a:t>
+              <a:t>chemin relatif au fichier ; front-matter retiré.</a:t>
             </a:r>
           </a:p>
           <a:p>
             <a:pPr>
               <a:lnSpc>
-                <a:spcPct val="105000"/>
+                <a:spcPct val="104000"/>
               </a:lnSpc>
               <a:spcAft>
-                <a:spcPts val="1000"/>
+                <a:spcPts val="900"/>
               </a:spcAft>
             </a:pPr>
             <a:r>
-              <a:rPr sz="1700" b="1">
+              <a:rPr sz="1600" b="1">
                 <a:solidFill>
                   <a:srgbClr val="FFCC00"/>
                 </a:solidFill>
@@ -4824,93 +4730,57 @@
               <a:t>•  </a:t>
             </a:r>
             <a:r>
-              <a:rPr sz="1700" b="1">
+              <a:rPr sz="1600" b="1">
                 <a:solidFill>
                   <a:srgbClr val="003399"/>
                 </a:solidFill>
               </a:rPr>
-              <a:t>Inclusions imbriquées — </a:t>
-            </a:r>
-            <a:r>
-              <a:rPr sz="1700">
+              <a:t>Astuce — </a:t>
+            </a:r>
+            <a:r>
+              <a:rPr sz="1600">
                 <a:solidFill>
                   <a:srgbClr val="1A1A2E"/>
                 </a:solidFill>
               </a:rPr>
-              <a:t>un fragment peut lui-même en inclure d'autres.</a:t>
-            </a:r>
-          </a:p>
-          <a:p>
-            <a:pPr>
-              <a:lnSpc>
-                <a:spcPct val="105000"/>
-              </a:lnSpc>
-              <a:spcAft>
-                <a:spcPts val="1000"/>
-              </a:spcAft>
-            </a:pPr>
-            <a:r>
-              <a:rPr sz="1500" b="1">
-                <a:solidFill>
-                  <a:srgbClr val="1B4FA0"/>
-                </a:solidFill>
-              </a:rPr>
-              <a:t>    –  </a:t>
-            </a:r>
-            <a:r>
-              <a:rPr sz="1500">
-                <a:solidFill>
-                  <a:srgbClr val="4A4A4A"/>
-                </a:solidFill>
-              </a:rPr>
-              <a:t>détection des cycles (inclusion circulaire) avec erreur explicite.</a:t>
-            </a:r>
-          </a:p>
-          <a:p>
-            <a:pPr>
-              <a:lnSpc>
-                <a:spcPct val="105000"/>
-              </a:lnSpc>
-              <a:spcAft>
-                <a:spcPts val="1000"/>
-              </a:spcAft>
-            </a:pPr>
-            <a:r>
-              <a:rPr sz="1700" b="1">
-                <a:solidFill>
-                  <a:srgbClr val="FFCC00"/>
-                </a:solidFill>
-              </a:rPr>
-              <a:t>•  </a:t>
-            </a:r>
-            <a:r>
-              <a:rPr sz="1700" b="1">
-                <a:solidFill>
-                  <a:srgbClr val="003399"/>
-                </a:solidFill>
-              </a:rPr>
-              <a:t>Robustesse — </a:t>
-            </a:r>
-            <a:r>
-              <a:rPr sz="1700">
-                <a:solidFill>
-                  <a:srgbClr val="1A1A2E"/>
-                </a:solidFill>
-              </a:rPr>
-              <a:t>détection sur le texte source brut → pas de pièges Markdown (ex. les _ dans les noms de fichiers).</a:t>
-            </a:r>
-          </a:p>
-        </p:txBody>
-      </p:sp>
-      <p:sp>
-        <p:nvSpPr>
-          <p:cNvPr id="7" name="TextBox 6"/>
+              <a:t>un dossier _fragments/ (underscore) reste hors de la sidebar.</a:t>
+            </a:r>
+          </a:p>
+        </p:txBody>
+      </p:sp>
+      <p:pic>
+        <p:nvPicPr>
+          <p:cNvPr id="7" name="Picture 6" descr="01-include-usage.png"/>
+          <p:cNvPicPr>
+            <a:picLocks noChangeAspect="1"/>
+          </p:cNvPicPr>
+          <p:nvPr/>
+        </p:nvPicPr>
+        <p:blipFill>
+          <a:blip r:embed="rId2"/>
+          <a:stretch>
+            <a:fillRect/>
+          </a:stretch>
+        </p:blipFill>
+        <p:spPr>
+          <a:xfrm>
+            <a:off x="5806440" y="2302956"/>
+            <a:ext cx="6035040" cy="3166486"/>
+          </a:xfrm>
+          <a:prstGeom prst="rect">
+            <a:avLst/>
+          </a:prstGeom>
+        </p:spPr>
+      </p:pic>
+      <p:sp>
+        <p:nvSpPr>
+          <p:cNvPr id="8" name="TextBox 7"/>
           <p:cNvSpPr txBox="1"/>
           <p:nvPr/>
         </p:nvSpPr>
         <p:spPr>
           <a:xfrm>
-            <a:off x="640080" y="6400800"/>
+            <a:off x="640080" y="6419088"/>
             <a:ext cx="9144000" cy="320040"/>
           </a:xfrm>
           <a:prstGeom prst="rect">
@@ -4924,35 +4794,28 @@
           </a:bodyPr>
           <a:lstStyle/>
           <a:p>
-            <a:pPr algn="l">
-              <a:lnSpc>
-                <a:spcPct val="100000"/>
-              </a:lnSpc>
-              <a:spcAft>
-                <a:spcPts val="600"/>
-              </a:spcAft>
-            </a:pPr>
-            <a:r>
-              <a:rPr sz="900" b="0" i="0">
+            <a:pPr algn="l"/>
+            <a:r>
+              <a:rPr sz="900" b="0">
                 <a:solidFill>
                   <a:srgbClr val="4A4A4A"/>
                 </a:solidFill>
                 <a:latin typeface="Calibri"/>
               </a:rPr>
-              <a:t>Plateforme de documentation Docusaurus — features implémentées</a:t>
-            </a:r>
-          </a:p>
-        </p:txBody>
-      </p:sp>
-      <p:sp>
-        <p:nvSpPr>
-          <p:cNvPr id="8" name="TextBox 7"/>
+              <a:t>Docusaurus — guide d'utilisation</a:t>
+            </a:r>
+          </a:p>
+        </p:txBody>
+      </p:sp>
+      <p:sp>
+        <p:nvSpPr>
+          <p:cNvPr id="9" name="TextBox 8"/>
           <p:cNvSpPr txBox="1"/>
           <p:nvPr/>
         </p:nvSpPr>
         <p:spPr>
           <a:xfrm>
-            <a:off x="11247120" y="6400800"/>
+            <a:off x="11247120" y="6419088"/>
             <a:ext cx="731520" cy="320040"/>
           </a:xfrm>
           <a:prstGeom prst="rect">
@@ -4966,16 +4829,9 @@
           </a:bodyPr>
           <a:lstStyle/>
           <a:p>
-            <a:pPr algn="r">
-              <a:lnSpc>
-                <a:spcPct val="100000"/>
-              </a:lnSpc>
-              <a:spcAft>
-                <a:spcPts val="600"/>
-              </a:spcAft>
-            </a:pPr>
-            <a:r>
-              <a:rPr sz="900" b="1" i="0">
+            <a:pPr algn="r"/>
+            <a:r>
+              <a:rPr sz="900" b="1">
                 <a:solidFill>
                   <a:srgbClr val="4A4A4A"/>
                 </a:solidFill>
@@ -5070,22 +4926,15 @@
           </a:bodyPr>
           <a:lstStyle/>
           <a:p>
-            <a:pPr algn="l">
-              <a:lnSpc>
-                <a:spcPct val="100000"/>
-              </a:lnSpc>
-              <a:spcAft>
-                <a:spcPts val="600"/>
-              </a:spcAft>
-            </a:pPr>
-            <a:r>
-              <a:rPr sz="1300" b="1" i="0">
+            <a:pPr algn="l"/>
+            <a:r>
+              <a:rPr sz="1300" b="1">
                 <a:solidFill>
                   <a:srgbClr val="1B4FA0"/>
                 </a:solidFill>
                 <a:latin typeface="Calibri"/>
               </a:rPr>
-              <a:t>FEATURE 2 — EXPÉRIENCE DÉVELOPPEUR</a:t>
+              <a:t>PRÉVISUALISER — FLUX DE TRAVAIL</a:t>
             </a:r>
           </a:p>
         </p:txBody>
@@ -5112,22 +4961,15 @@
           </a:bodyPr>
           <a:lstStyle/>
           <a:p>
-            <a:pPr algn="l">
-              <a:lnSpc>
-                <a:spcPct val="100000"/>
-              </a:lnSpc>
-              <a:spcAft>
-                <a:spcPts val="600"/>
-              </a:spcAft>
-            </a:pPr>
-            <a:r>
-              <a:rPr sz="3000" b="1" i="0">
+            <a:pPr algn="l"/>
+            <a:r>
+              <a:rPr sz="2800" b="1">
                 <a:solidFill>
                   <a:srgbClr val="003399"/>
                 </a:solidFill>
                 <a:latin typeface="Calibri"/>
               </a:rPr>
-              <a:t>Live-reload des fragments</a:t>
+              <a:t>Lancer et prévisualiser le site</a:t>
             </a:r>
           </a:p>
         </p:txBody>
@@ -5140,7 +4982,7 @@
         </p:nvSpPr>
         <p:spPr>
           <a:xfrm>
-            <a:off x="658368" y="1554480"/>
+            <a:off x="658368" y="1481328"/>
             <a:ext cx="2011680" cy="38100"/>
           </a:xfrm>
           <a:prstGeom prst="rect">
@@ -5184,8 +5026,8 @@
         </p:nvSpPr>
         <p:spPr>
           <a:xfrm>
-            <a:off x="658368" y="1920240"/>
-            <a:ext cx="10881360" cy="4297680"/>
+            <a:off x="658368" y="1828800"/>
+            <a:ext cx="10881360" cy="4389120"/>
           </a:xfrm>
           <a:prstGeom prst="rect">
             <a:avLst/>
@@ -5200,14 +5042,14 @@
           <a:p>
             <a:pPr>
               <a:lnSpc>
-                <a:spcPct val="105000"/>
+                <a:spcPct val="104000"/>
               </a:lnSpc>
               <a:spcAft>
-                <a:spcPts val="1000"/>
+                <a:spcPts val="900"/>
               </a:spcAft>
             </a:pPr>
             <a:r>
-              <a:rPr sz="1700" b="1">
+              <a:rPr sz="1600" b="1">
                 <a:solidFill>
                   <a:srgbClr val="FFCC00"/>
                 </a:solidFill>
@@ -5215,33 +5057,33 @@
               <a:t>•  </a:t>
             </a:r>
             <a:r>
-              <a:rPr sz="1700" b="1">
+              <a:rPr sz="1600" b="1">
                 <a:solidFill>
                   <a:srgbClr val="003399"/>
                 </a:solidFill>
               </a:rPr>
-              <a:t>Problème — </a:t>
-            </a:r>
-            <a:r>
-              <a:rPr sz="1700">
+              <a:t>make dev — </a:t>
+            </a:r>
+            <a:r>
+              <a:rPr sz="1600">
                 <a:solidFill>
                   <a:srgbClr val="1A1A2E"/>
                 </a:solidFill>
               </a:rPr>
-              <a:t>le plugin remark lit les fragments via fs ; webpack ignore cette dépendance et ne recompile pas la page quand un fragment change.</a:t>
+              <a:t>démarre le serveur local avec aperçu en direct.</a:t>
             </a:r>
           </a:p>
           <a:p>
             <a:pPr>
               <a:lnSpc>
-                <a:spcPct val="105000"/>
+                <a:spcPct val="104000"/>
               </a:lnSpc>
               <a:spcAft>
-                <a:spcPts val="1000"/>
+                <a:spcPts val="900"/>
               </a:spcAft>
             </a:pPr>
             <a:r>
-              <a:rPr sz="1700" b="1">
+              <a:rPr sz="1600" b="1">
                 <a:solidFill>
                   <a:srgbClr val="FFCC00"/>
                 </a:solidFill>
@@ -5249,85 +5091,67 @@
               <a:t>•  </a:t>
             </a:r>
             <a:r>
-              <a:rPr sz="1700" b="1">
+              <a:rPr sz="1600" b="1">
                 <a:solidFill>
                   <a:srgbClr val="003399"/>
                 </a:solidFill>
               </a:rPr>
-              <a:t>Solution — </a:t>
-            </a:r>
-            <a:r>
-              <a:rPr sz="1700">
+              <a:t>Hot reload — </a:t>
+            </a:r>
+            <a:r>
+              <a:rPr sz="1600">
                 <a:solidFill>
                   <a:srgbClr val="1A1A2E"/>
                 </a:solidFill>
               </a:rPr>
-              <a:t>un pre-loader webpack déclare chaque fichier inclus comme dépendance de la page.</a:t>
+              <a:t>modifiez une page ou un fragment inclus → l'aperçu se met à jour seul.</a:t>
             </a:r>
           </a:p>
           <a:p>
             <a:pPr>
               <a:lnSpc>
-                <a:spcPct val="105000"/>
+                <a:spcPct val="104000"/>
               </a:lnSpc>
               <a:spcAft>
-                <a:spcPts val="1000"/>
+                <a:spcPts val="900"/>
               </a:spcAft>
             </a:pPr>
             <a:r>
-              <a:rPr sz="1500" b="1">
-                <a:solidFill>
-                  <a:srgbClr val="1B4FA0"/>
-                </a:solidFill>
-              </a:rPr>
-              <a:t>    –  </a:t>
-            </a:r>
-            <a:r>
-              <a:rPr sz="1500">
-                <a:solidFill>
-                  <a:srgbClr val="4A4A4A"/>
-                </a:solidFill>
-              </a:rPr>
-              <a:t>appel récursif de this.addDependency() pour chaque #include (et leurs imbrications).</a:t>
+              <a:rPr sz="1600" b="1">
+                <a:solidFill>
+                  <a:srgbClr val="FFCC00"/>
+                </a:solidFill>
+              </a:rPr>
+              <a:t>•  </a:t>
+            </a:r>
+            <a:r>
+              <a:rPr sz="1600" b="1">
+                <a:solidFill>
+                  <a:srgbClr val="003399"/>
+                </a:solidFill>
+              </a:rPr>
+              <a:t>make prod — </a:t>
+            </a:r>
+            <a:r>
+              <a:rPr sz="1600">
+                <a:solidFill>
+                  <a:srgbClr val="1A1A2E"/>
+                </a:solidFill>
+              </a:rPr>
+              <a:t>build de production servi derrière Caddy.</a:t>
             </a:r>
           </a:p>
           <a:p>
             <a:pPr>
               <a:lnSpc>
-                <a:spcPct val="105000"/>
+                <a:spcPct val="104000"/>
               </a:lnSpc>
               <a:spcAft>
-                <a:spcPts val="1000"/>
+                <a:spcPts val="900"/>
               </a:spcAft>
             </a:pPr>
             <a:r>
-              <a:rPr sz="1500" b="1">
-                <a:solidFill>
-                  <a:srgbClr val="1B4FA0"/>
-                </a:solidFill>
-              </a:rPr>
-              <a:t>    –  </a:t>
-            </a:r>
-            <a:r>
-              <a:rPr sz="1500">
-                <a:solidFill>
-                  <a:srgbClr val="4A4A4A"/>
-                </a:solidFill>
-              </a:rPr>
-              <a:t>la source reste inchangée : le loader ne fait qu'enregistrer les dépendances.</a:t>
-            </a:r>
-          </a:p>
-          <a:p>
-            <a:pPr>
-              <a:lnSpc>
-                <a:spcPct val="105000"/>
-              </a:lnSpc>
-              <a:spcAft>
-                <a:spcPts val="1000"/>
-              </a:spcAft>
-            </a:pPr>
-            <a:r>
-              <a:rPr sz="1700" b="1">
+              <a:rPr sz="1600" b="1">
                 <a:solidFill>
                   <a:srgbClr val="FFCC00"/>
                 </a:solidFill>
@@ -5335,20 +5159,20 @@
               <a:t>•  </a:t>
             </a:r>
             <a:r>
-              <a:rPr sz="1700" b="1">
+              <a:rPr sz="1600" b="1">
                 <a:solidFill>
                   <a:srgbClr val="003399"/>
                 </a:solidFill>
               </a:rPr>
-              <a:t>Résultat — </a:t>
-            </a:r>
-            <a:r>
-              <a:rPr sz="1700">
+              <a:t>Pas d'outillage à installer — </a:t>
+            </a:r>
+            <a:r>
+              <a:rPr sz="1600">
                 <a:solidFill>
                   <a:srgbClr val="1A1A2E"/>
                 </a:solidFill>
               </a:rPr>
-              <a:t>le hot reload fonctionne — modifier un fragment rafraîchit instantanément toutes les pages qui l'incluent.</a:t>
+              <a:t>tout passe par Docker / docker-compose.</a:t>
             </a:r>
           </a:p>
         </p:txBody>
@@ -5361,7 +5185,7 @@
         </p:nvSpPr>
         <p:spPr>
           <a:xfrm>
-            <a:off x="640080" y="6400800"/>
+            <a:off x="640080" y="6419088"/>
             <a:ext cx="9144000" cy="320040"/>
           </a:xfrm>
           <a:prstGeom prst="rect">
@@ -5375,22 +5199,15 @@
           </a:bodyPr>
           <a:lstStyle/>
           <a:p>
-            <a:pPr algn="l">
-              <a:lnSpc>
-                <a:spcPct val="100000"/>
-              </a:lnSpc>
-              <a:spcAft>
-                <a:spcPts val="600"/>
-              </a:spcAft>
-            </a:pPr>
-            <a:r>
-              <a:rPr sz="900" b="0" i="0">
+            <a:pPr algn="l"/>
+            <a:r>
+              <a:rPr sz="900" b="0">
                 <a:solidFill>
                   <a:srgbClr val="4A4A4A"/>
                 </a:solidFill>
                 <a:latin typeface="Calibri"/>
               </a:rPr>
-              <a:t>Plateforme de documentation Docusaurus — features implémentées</a:t>
+              <a:t>Docusaurus — guide d'utilisation</a:t>
             </a:r>
           </a:p>
         </p:txBody>
@@ -5403,7 +5220,7 @@
         </p:nvSpPr>
         <p:spPr>
           <a:xfrm>
-            <a:off x="11247120" y="6400800"/>
+            <a:off x="11247120" y="6419088"/>
             <a:ext cx="731520" cy="320040"/>
           </a:xfrm>
           <a:prstGeom prst="rect">
@@ -5417,16 +5234,9 @@
           </a:bodyPr>
           <a:lstStyle/>
           <a:p>
-            <a:pPr algn="r">
-              <a:lnSpc>
-                <a:spcPct val="100000"/>
-              </a:lnSpc>
-              <a:spcAft>
-                <a:spcPts val="600"/>
-              </a:spcAft>
-            </a:pPr>
-            <a:r>
-              <a:rPr sz="900" b="1" i="0">
+            <a:pPr algn="r"/>
+            <a:r>
+              <a:rPr sz="900" b="1">
                 <a:solidFill>
                   <a:srgbClr val="4A4A4A"/>
                 </a:solidFill>
@@ -5521,22 +5331,15 @@
           </a:bodyPr>
           <a:lstStyle/>
           <a:p>
-            <a:pPr algn="l">
-              <a:lnSpc>
-                <a:spcPct val="100000"/>
-              </a:lnSpc>
-              <a:spcAft>
-                <a:spcPts val="600"/>
-              </a:spcAft>
-            </a:pPr>
-            <a:r>
-              <a:rPr sz="1300" b="1" i="0">
+            <a:pPr algn="l"/>
+            <a:r>
+              <a:rPr sz="1300" b="1">
                 <a:solidFill>
                   <a:srgbClr val="1B4FA0"/>
                 </a:solidFill>
                 <a:latin typeface="Calibri"/>
               </a:rPr>
-              <a:t>FEATURE 3 — RÉUTILISATION DE CONTENU</a:t>
+              <a:t>RÉUTILISER — UNE SEULE SOURCE DE VÉRITÉ</a:t>
             </a:r>
           </a:p>
         </p:txBody>
@@ -5563,22 +5366,15 @@
           </a:bodyPr>
           <a:lstStyle/>
           <a:p>
-            <a:pPr algn="l">
-              <a:lnSpc>
-                <a:spcPct val="100000"/>
-              </a:lnSpc>
-              <a:spcAft>
-                <a:spcPts val="600"/>
-              </a:spcAft>
-            </a:pPr>
-            <a:r>
-              <a:rPr sz="3000" b="1" i="0">
+            <a:pPr algn="l"/>
+            <a:r>
+              <a:rPr sz="2800" b="1">
                 <a:solidFill>
                   <a:srgbClr val="003399"/>
                 </a:solidFill>
                 <a:latin typeface="Calibri"/>
               </a:rPr>
-              <a:t>Partials &amp; composants réutilisables</a:t>
+              <a:t>Blocs réutilisables : « Prérequis »</a:t>
             </a:r>
           </a:p>
         </p:txBody>
@@ -5591,7 +5387,7 @@
         </p:nvSpPr>
         <p:spPr>
           <a:xfrm>
-            <a:off x="658368" y="1554480"/>
+            <a:off x="658368" y="1481328"/>
             <a:ext cx="2011680" cy="38100"/>
           </a:xfrm>
           <a:prstGeom prst="rect">
@@ -5635,8 +5431,8 @@
         </p:nvSpPr>
         <p:spPr>
           <a:xfrm>
-            <a:off x="658368" y="1920240"/>
-            <a:ext cx="10881360" cy="4297680"/>
+            <a:off x="658368" y="1828800"/>
+            <a:ext cx="10881360" cy="4389120"/>
           </a:xfrm>
           <a:prstGeom prst="rect">
             <a:avLst/>
@@ -5651,14 +5447,14 @@
           <a:p>
             <a:pPr>
               <a:lnSpc>
-                <a:spcPct val="105000"/>
+                <a:spcPct val="104000"/>
               </a:lnSpc>
               <a:spcAft>
-                <a:spcPts val="1000"/>
+                <a:spcPts val="900"/>
               </a:spcAft>
             </a:pPr>
             <a:r>
-              <a:rPr sz="1700" b="1">
+              <a:rPr sz="1600" b="1">
                 <a:solidFill>
                   <a:srgbClr val="FFCC00"/>
                 </a:solidFill>
@@ -5666,33 +5462,33 @@
               <a:t>•  </a:t>
             </a:r>
             <a:r>
-              <a:rPr sz="1700" b="1">
+              <a:rPr sz="1600" b="1">
                 <a:solidFill>
                   <a:srgbClr val="003399"/>
                 </a:solidFill>
               </a:rPr>
-              <a:t>Partial « Prérequis » — </a:t>
-            </a:r>
-            <a:r>
-              <a:rPr sz="1700">
+              <a:t>Partial Markdown — </a:t>
+            </a:r>
+            <a:r>
+              <a:rPr sz="1600">
                 <a:solidFill>
                   <a:srgbClr val="1A1A2E"/>
                 </a:solidFill>
               </a:rPr>
-              <a:t>bloc Markdown réutilisable factorisé (docs/_chapters, _fragments).</a:t>
+              <a:t>factorisez un bloc récurrent (ex. « Prérequis ») dans un fichier.</a:t>
             </a:r>
           </a:p>
           <a:p>
             <a:pPr>
               <a:lnSpc>
-                <a:spcPct val="105000"/>
+                <a:spcPct val="104000"/>
               </a:lnSpc>
               <a:spcAft>
-                <a:spcPts val="1000"/>
+                <a:spcPts val="900"/>
               </a:spcAft>
             </a:pPr>
             <a:r>
-              <a:rPr sz="1700" b="1">
+              <a:rPr sz="1600" b="1">
                 <a:solidFill>
                   <a:srgbClr val="FFCC00"/>
                 </a:solidFill>
@@ -5700,7 +5496,7 @@
               <a:t>•  </a:t>
             </a:r>
             <a:r>
-              <a:rPr sz="1700" b="1">
+              <a:rPr sz="1600" b="1">
                 <a:solidFill>
                   <a:srgbClr val="003399"/>
                 </a:solidFill>
@@ -5708,25 +5504,25 @@
               <a:t>Composant MDX global — </a:t>
             </a:r>
             <a:r>
-              <a:rPr sz="1700">
+              <a:rPr sz="1600">
                 <a:solidFill>
                   <a:srgbClr val="1A1A2E"/>
                 </a:solidFill>
               </a:rPr>
-              <a:t>Prerequis enregistré globalement → utilisable dans n'importe quelle page sans import.</a:t>
+              <a:t>utilisable dans n'importe quelle page, sans import.</a:t>
             </a:r>
           </a:p>
           <a:p>
             <a:pPr>
               <a:lnSpc>
-                <a:spcPct val="105000"/>
+                <a:spcPct val="104000"/>
               </a:lnSpc>
               <a:spcAft>
-                <a:spcPts val="1000"/>
+                <a:spcPts val="900"/>
               </a:spcAft>
             </a:pPr>
             <a:r>
-              <a:rPr sz="1700" b="1">
+              <a:rPr sz="1600" b="1">
                 <a:solidFill>
                   <a:srgbClr val="FFCC00"/>
                 </a:solidFill>
@@ -5734,33 +5530,33 @@
               <a:t>•  </a:t>
             </a:r>
             <a:r>
-              <a:rPr sz="1700" b="1">
+              <a:rPr sz="1600" b="1">
                 <a:solidFill>
                   <a:srgbClr val="003399"/>
                 </a:solidFill>
               </a:rPr>
-              <a:t>Fragments d'architecture — </a:t>
-            </a:r>
-            <a:r>
-              <a:rPr sz="1700">
+              <a:t>Inclusions imbriquées — </a:t>
+            </a:r>
+            <a:r>
+              <a:rPr sz="1600">
                 <a:solidFill>
                   <a:srgbClr val="1A1A2E"/>
                 </a:solidFill>
               </a:rPr>
-              <a:t>_fragments/level-1-context.md, level-2-components.md inclus dans les chapitres.</a:t>
+              <a:t>un fragment peut en inclure d'autres (cycles détectés).</a:t>
             </a:r>
           </a:p>
           <a:p>
             <a:pPr>
               <a:lnSpc>
-                <a:spcPct val="105000"/>
+                <a:spcPct val="104000"/>
               </a:lnSpc>
               <a:spcAft>
-                <a:spcPts val="1000"/>
+                <a:spcPts val="900"/>
               </a:spcAft>
             </a:pPr>
             <a:r>
-              <a:rPr sz="1700" b="1">
+              <a:rPr sz="1600" b="1">
                 <a:solidFill>
                   <a:srgbClr val="FFCC00"/>
                 </a:solidFill>
@@ -5768,7 +5564,7 @@
               <a:t>•  </a:t>
             </a:r>
             <a:r>
-              <a:rPr sz="1700" b="1">
+              <a:rPr sz="1600" b="1">
                 <a:solidFill>
                   <a:srgbClr val="003399"/>
                 </a:solidFill>
@@ -5776,12 +5572,12 @@
               <a:t>Bénéfice — </a:t>
             </a:r>
             <a:r>
-              <a:rPr sz="1700">
+              <a:rPr sz="1600">
                 <a:solidFill>
                   <a:srgbClr val="1A1A2E"/>
                 </a:solidFill>
               </a:rPr>
-              <a:t>une seule source de vérité : on met à jour le fragment, toutes les pages suivent.</a:t>
+              <a:t>mettez à jour le bloc une fois → toutes les pages suivent.</a:t>
             </a:r>
           </a:p>
         </p:txBody>
@@ -5794,7 +5590,7 @@
         </p:nvSpPr>
         <p:spPr>
           <a:xfrm>
-            <a:off x="640080" y="6400800"/>
+            <a:off x="640080" y="6419088"/>
             <a:ext cx="9144000" cy="320040"/>
           </a:xfrm>
           <a:prstGeom prst="rect">
@@ -5808,22 +5604,15 @@
           </a:bodyPr>
           <a:lstStyle/>
           <a:p>
-            <a:pPr algn="l">
-              <a:lnSpc>
-                <a:spcPct val="100000"/>
-              </a:lnSpc>
-              <a:spcAft>
-                <a:spcPts val="600"/>
-              </a:spcAft>
-            </a:pPr>
-            <a:r>
-              <a:rPr sz="900" b="0" i="0">
+            <a:pPr algn="l"/>
+            <a:r>
+              <a:rPr sz="900" b="0">
                 <a:solidFill>
                   <a:srgbClr val="4A4A4A"/>
                 </a:solidFill>
                 <a:latin typeface="Calibri"/>
               </a:rPr>
-              <a:t>Plateforme de documentation Docusaurus — features implémentées</a:t>
+              <a:t>Docusaurus — guide d'utilisation</a:t>
             </a:r>
           </a:p>
         </p:txBody>
@@ -5836,7 +5625,7 @@
         </p:nvSpPr>
         <p:spPr>
           <a:xfrm>
-            <a:off x="11247120" y="6400800"/>
+            <a:off x="11247120" y="6419088"/>
             <a:ext cx="731520" cy="320040"/>
           </a:xfrm>
           <a:prstGeom prst="rect">
@@ -5850,16 +5639,9 @@
           </a:bodyPr>
           <a:lstStyle/>
           <a:p>
-            <a:pPr algn="r">
-              <a:lnSpc>
-                <a:spcPct val="100000"/>
-              </a:lnSpc>
-              <a:spcAft>
-                <a:spcPts val="600"/>
-              </a:spcAft>
-            </a:pPr>
-            <a:r>
-              <a:rPr sz="900" b="1" i="0">
+            <a:pPr algn="r"/>
+            <a:r>
+              <a:rPr sz="900" b="1">
                 <a:solidFill>
                   <a:srgbClr val="4A4A4A"/>
                 </a:solidFill>
@@ -5954,22 +5736,15 @@
           </a:bodyPr>
           <a:lstStyle/>
           <a:p>
-            <a:pPr algn="l">
-              <a:lnSpc>
-                <a:spcPct val="100000"/>
-              </a:lnSpc>
-              <a:spcAft>
-                <a:spcPts val="600"/>
-              </a:spcAft>
-            </a:pPr>
-            <a:r>
-              <a:rPr sz="1300" b="1" i="0">
+            <a:pPr algn="l"/>
+            <a:r>
+              <a:rPr sz="1300" b="1">
                 <a:solidFill>
                   <a:srgbClr val="1B4FA0"/>
                 </a:solidFill>
                 <a:latin typeface="Calibri"/>
               </a:rPr>
-              <a:t>FEATURE 4 — ARCHITECTURE AS CODE</a:t>
+              <a:t>ILLUSTRER — DIAGRAMMES D'ARCHITECTURE</a:t>
             </a:r>
           </a:p>
         </p:txBody>
@@ -5996,22 +5771,15 @@
           </a:bodyPr>
           <a:lstStyle/>
           <a:p>
-            <a:pPr algn="l">
-              <a:lnSpc>
-                <a:spcPct val="100000"/>
-              </a:lnSpc>
-              <a:spcAft>
-                <a:spcPts val="600"/>
-              </a:spcAft>
-            </a:pPr>
-            <a:r>
-              <a:rPr sz="3000" b="1" i="0">
+            <a:pPr algn="l"/>
+            <a:r>
+              <a:rPr sz="2800" b="1">
                 <a:solidFill>
                   <a:srgbClr val="003399"/>
                 </a:solidFill>
                 <a:latin typeface="Calibri"/>
               </a:rPr>
-              <a:t>Diagrammes d'architecture</a:t>
+              <a:t>LikeC4 &amp; tldraw</a:t>
             </a:r>
           </a:p>
         </p:txBody>
@@ -6024,7 +5792,7 @@
         </p:nvSpPr>
         <p:spPr>
           <a:xfrm>
-            <a:off x="658368" y="1554480"/>
+            <a:off x="658368" y="1481328"/>
             <a:ext cx="2011680" cy="38100"/>
           </a:xfrm>
           <a:prstGeom prst="rect">
@@ -6068,8 +5836,8 @@
         </p:nvSpPr>
         <p:spPr>
           <a:xfrm>
-            <a:off x="658368" y="1920240"/>
-            <a:ext cx="10881360" cy="4297680"/>
+            <a:off x="658368" y="1828800"/>
+            <a:ext cx="10881360" cy="4389120"/>
           </a:xfrm>
           <a:prstGeom prst="rect">
             <a:avLst/>
@@ -6084,14 +5852,14 @@
           <a:p>
             <a:pPr>
               <a:lnSpc>
-                <a:spcPct val="105000"/>
+                <a:spcPct val="104000"/>
               </a:lnSpc>
               <a:spcAft>
-                <a:spcPts val="1000"/>
+                <a:spcPts val="900"/>
               </a:spcAft>
             </a:pPr>
             <a:r>
-              <a:rPr sz="1700" b="1">
+              <a:rPr sz="1600" b="1">
                 <a:solidFill>
                   <a:srgbClr val="FFCC00"/>
                 </a:solidFill>
@@ -6099,7 +5867,7 @@
               <a:t>•  </a:t>
             </a:r>
             <a:r>
-              <a:rPr sz="1700" b="1">
+              <a:rPr sz="1600" b="1">
                 <a:solidFill>
                   <a:srgbClr val="003399"/>
                 </a:solidFill>
@@ -6107,77 +5875,77 @@
               <a:t>LikeC4 — </a:t>
             </a:r>
             <a:r>
-              <a:rPr sz="1700">
+              <a:rPr sz="1600">
                 <a:solidFill>
                   <a:srgbClr val="1A1A2E"/>
                 </a:solidFill>
               </a:rPr>
-              <a:t>modèle d'architecture as code (C4) : spec, modèle, vues, déploiements (dev / prod), use-cases.</a:t>
+              <a:t>diagrammes d'architecture (modèle C4) décrits en texte.</a:t>
             </a:r>
           </a:p>
           <a:p>
             <a:pPr>
               <a:lnSpc>
-                <a:spcPct val="105000"/>
+                <a:spcPct val="104000"/>
               </a:lnSpc>
               <a:spcAft>
-                <a:spcPts val="1000"/>
+                <a:spcPts val="900"/>
               </a:spcAft>
             </a:pPr>
             <a:r>
-              <a:rPr sz="1500" b="1">
+              <a:rPr sz="1400" b="1">
                 <a:solidFill>
                   <a:srgbClr val="1B4FA0"/>
                 </a:solidFill>
               </a:rPr>
-              <a:t>    –  </a:t>
-            </a:r>
-            <a:r>
-              <a:rPr sz="1500">
+              <a:t>   –  </a:t>
+            </a:r>
+            <a:r>
+              <a:rPr sz="1400">
                 <a:solidFill>
                   <a:srgbClr val="4A4A4A"/>
                 </a:solidFill>
               </a:rPr>
-              <a:t>génération de diagrammes statiques (build-likec4) et de composants React interactifs (codegen).</a:t>
+              <a:t>page /likec4 pour explorer le diagramme interactif.</a:t>
             </a:r>
           </a:p>
           <a:p>
             <a:pPr>
               <a:lnSpc>
-                <a:spcPct val="105000"/>
+                <a:spcPct val="104000"/>
               </a:lnSpc>
               <a:spcAft>
-                <a:spcPts val="1000"/>
+                <a:spcPts val="900"/>
               </a:spcAft>
             </a:pPr>
             <a:r>
-              <a:rPr sz="1500" b="1">
+              <a:rPr sz="1400" b="1">
                 <a:solidFill>
                   <a:srgbClr val="1B4FA0"/>
                 </a:solidFill>
               </a:rPr>
-              <a:t>    –  </a:t>
-            </a:r>
-            <a:r>
-              <a:rPr sz="1500">
+              <a:t>   –  </a:t>
+            </a:r>
+            <a:r>
+              <a:rPr sz="1400">
                 <a:solidFill>
                   <a:srgbClr val="4A4A4A"/>
                 </a:solidFill>
               </a:rPr>
-              <a:t>page dédiée /likec4 pour explorer le diagramme interactif.</a:t>
+              <a:t>vues : contexte, composants, déploiements dev / prod, use-cases.</a:t>
             </a:r>
           </a:p>
           <a:p>
             <a:pPr>
               <a:lnSpc>
-                <a:spcPct val="105000"/>
+                <a:spcPct val="104000"/>
               </a:lnSpc>
               <a:spcAft>
-                <a:spcPts val="1000"/>
+                <a:spcPts val="900"/>
               </a:spcAft>
             </a:pPr>
             <a:r>
-              <a:rPr sz="1700" b="1">
+              <a:rPr sz="1600" b="1">
                 <a:solidFill>
                   <a:srgbClr val="FFCC00"/>
                 </a:solidFill>
@@ -6185,7 +5953,7 @@
               <a:t>•  </a:t>
             </a:r>
             <a:r>
-              <a:rPr sz="1700" b="1">
+              <a:rPr sz="1600" b="1">
                 <a:solidFill>
                   <a:srgbClr val="003399"/>
                 </a:solidFill>
@@ -6193,25 +5961,25 @@
               <a:t>tldraw — </a:t>
             </a:r>
             <a:r>
-              <a:rPr sz="1700">
+              <a:rPr sz="1600">
                 <a:solidFill>
                   <a:srgbClr val="1A1A2E"/>
                 </a:solidFill>
               </a:rPr>
-              <a:t>page /tldraw pour les schémas libres et le whiteboarding intégré au site.</a:t>
+              <a:t>page /tldraw pour des schémas libres et le whiteboarding.</a:t>
             </a:r>
           </a:p>
           <a:p>
             <a:pPr>
               <a:lnSpc>
-                <a:spcPct val="105000"/>
+                <a:spcPct val="104000"/>
               </a:lnSpc>
               <a:spcAft>
-                <a:spcPts val="1000"/>
+                <a:spcPts val="900"/>
               </a:spcAft>
             </a:pPr>
             <a:r>
-              <a:rPr sz="1700" b="1">
+              <a:rPr sz="1600" b="1">
                 <a:solidFill>
                   <a:srgbClr val="FFCC00"/>
                 </a:solidFill>
@@ -6219,20 +5987,20 @@
               <a:t>•  </a:t>
             </a:r>
             <a:r>
-              <a:rPr sz="1700" b="1">
+              <a:rPr sz="1600" b="1">
                 <a:solidFill>
                   <a:srgbClr val="003399"/>
                 </a:solidFill>
               </a:rPr>
-              <a:t>Docs d'architecture — </a:t>
-            </a:r>
-            <a:r>
-              <a:rPr sz="1700">
+              <a:t>Docs d'archi — </a:t>
+            </a:r>
+            <a:r>
+              <a:rPr sz="1600">
                 <a:solidFill>
                   <a:srgbClr val="1A1A2E"/>
                 </a:solidFill>
               </a:rPr>
-              <a:t>chapitres structurés : executive summary, stakeholders, ADR, building blocks, non-functional…</a:t>
+              <a:t>chapitres prêts : résumé, parties prenantes, ADR, building blocks…</a:t>
             </a:r>
           </a:p>
         </p:txBody>
@@ -6245,7 +6013,7 @@
         </p:nvSpPr>
         <p:spPr>
           <a:xfrm>
-            <a:off x="640080" y="6400800"/>
+            <a:off x="640080" y="6419088"/>
             <a:ext cx="9144000" cy="320040"/>
           </a:xfrm>
           <a:prstGeom prst="rect">
@@ -6259,22 +6027,15 @@
           </a:bodyPr>
           <a:lstStyle/>
           <a:p>
-            <a:pPr algn="l">
-              <a:lnSpc>
-                <a:spcPct val="100000"/>
-              </a:lnSpc>
-              <a:spcAft>
-                <a:spcPts val="600"/>
-              </a:spcAft>
-            </a:pPr>
-            <a:r>
-              <a:rPr sz="900" b="0" i="0">
+            <a:pPr algn="l"/>
+            <a:r>
+              <a:rPr sz="900" b="0">
                 <a:solidFill>
                   <a:srgbClr val="4A4A4A"/>
                 </a:solidFill>
                 <a:latin typeface="Calibri"/>
               </a:rPr>
-              <a:t>Plateforme de documentation Docusaurus — features implémentées</a:t>
+              <a:t>Docusaurus — guide d'utilisation</a:t>
             </a:r>
           </a:p>
         </p:txBody>
@@ -6287,7 +6048,7 @@
         </p:nvSpPr>
         <p:spPr>
           <a:xfrm>
-            <a:off x="11247120" y="6400800"/>
+            <a:off x="11247120" y="6419088"/>
             <a:ext cx="731520" cy="320040"/>
           </a:xfrm>
           <a:prstGeom prst="rect">
@@ -6301,16 +6062,9 @@
           </a:bodyPr>
           <a:lstStyle/>
           <a:p>
-            <a:pPr algn="r">
-              <a:lnSpc>
-                <a:spcPct val="100000"/>
-              </a:lnSpc>
-              <a:spcAft>
-                <a:spcPts val="600"/>
-              </a:spcAft>
-            </a:pPr>
-            <a:r>
-              <a:rPr sz="900" b="1" i="0">
+            <a:pPr algn="r"/>
+            <a:r>
+              <a:rPr sz="900" b="1">
                 <a:solidFill>
                   <a:srgbClr val="4A4A4A"/>
                 </a:solidFill>
@@ -6405,22 +6159,15 @@
           </a:bodyPr>
           <a:lstStyle/>
           <a:p>
-            <a:pPr algn="l">
-              <a:lnSpc>
-                <a:spcPct val="100000"/>
-              </a:lnSpc>
-              <a:spcAft>
-                <a:spcPts val="600"/>
-              </a:spcAft>
-            </a:pPr>
-            <a:r>
-              <a:rPr sz="1300" b="1" i="0">
+            <a:pPr algn="l"/>
+            <a:r>
+              <a:rPr sz="1300" b="1">
                 <a:solidFill>
                   <a:srgbClr val="1B4FA0"/>
                 </a:solidFill>
                 <a:latin typeface="Calibri"/>
               </a:rPr>
-              <a:t>FEATURE 5 — WEASYPRINT</a:t>
+              <a:t>EXPORTER — PDF PROFESSIONNEL</a:t>
             </a:r>
           </a:p>
         </p:txBody>
@@ -6447,22 +6194,15 @@
           </a:bodyPr>
           <a:lstStyle/>
           <a:p>
-            <a:pPr algn="l">
-              <a:lnSpc>
-                <a:spcPct val="100000"/>
-              </a:lnSpc>
-              <a:spcAft>
-                <a:spcPts val="600"/>
-              </a:spcAft>
-            </a:pPr>
-            <a:r>
-              <a:rPr sz="3000" b="1" i="0">
+            <a:pPr algn="l"/>
+            <a:r>
+              <a:rPr sz="2800" b="1">
                 <a:solidFill>
                   <a:srgbClr val="003399"/>
                 </a:solidFill>
                 <a:latin typeface="Calibri"/>
               </a:rPr>
-              <a:t>Export PDF professionnel</a:t>
+              <a:t>Exporter la doc en PDF</a:t>
             </a:r>
           </a:p>
         </p:txBody>
@@ -6475,7 +6215,7 @@
         </p:nvSpPr>
         <p:spPr>
           <a:xfrm>
-            <a:off x="658368" y="1554480"/>
+            <a:off x="658368" y="1481328"/>
             <a:ext cx="2011680" cy="38100"/>
           </a:xfrm>
           <a:prstGeom prst="rect">
@@ -6519,8 +6259,8 @@
         </p:nvSpPr>
         <p:spPr>
           <a:xfrm>
-            <a:off x="658368" y="1920240"/>
-            <a:ext cx="10881360" cy="4297680"/>
+            <a:off x="658368" y="1828800"/>
+            <a:ext cx="5029200" cy="4389120"/>
           </a:xfrm>
           <a:prstGeom prst="rect">
             <a:avLst/>
@@ -6535,14 +6275,14 @@
           <a:p>
             <a:pPr>
               <a:lnSpc>
-                <a:spcPct val="105000"/>
+                <a:spcPct val="104000"/>
               </a:lnSpc>
               <a:spcAft>
-                <a:spcPts val="1000"/>
+                <a:spcPts val="900"/>
               </a:spcAft>
             </a:pPr>
             <a:r>
-              <a:rPr sz="1700" b="1">
+              <a:rPr sz="1600" b="1">
                 <a:solidFill>
                   <a:srgbClr val="FFCC00"/>
                 </a:solidFill>
@@ -6550,33 +6290,33 @@
               <a:t>•  </a:t>
             </a:r>
             <a:r>
-              <a:rPr sz="1700" b="1">
+              <a:rPr sz="1600" b="1">
                 <a:solidFill>
                   <a:srgbClr val="003399"/>
                 </a:solidFill>
               </a:rPr>
-              <a:t>Document unique — </a:t>
-            </a:r>
-            <a:r>
-              <a:rPr sz="1700">
+              <a:t>make pdf — </a:t>
+            </a:r>
+            <a:r>
+              <a:rPr sz="1600">
                 <a:solidFill>
                   <a:srgbClr val="1A1A2E"/>
                 </a:solidFill>
               </a:rPr>
-              <a:t>tout le dossier docs/ assemblé en un seul PDF (make pdf).</a:t>
+              <a:t>assemble toute la doc en un seul PDF brandé.</a:t>
             </a:r>
           </a:p>
           <a:p>
             <a:pPr>
               <a:lnSpc>
-                <a:spcPct val="105000"/>
+                <a:spcPct val="104000"/>
               </a:lnSpc>
               <a:spcAft>
-                <a:spcPts val="1000"/>
+                <a:spcPts val="900"/>
               </a:spcAft>
             </a:pPr>
             <a:r>
-              <a:rPr sz="1700" b="1">
+              <a:rPr sz="1600" b="1">
                 <a:solidFill>
                   <a:srgbClr val="FFCC00"/>
                 </a:solidFill>
@@ -6584,33 +6324,25 @@
               <a:t>•  </a:t>
             </a:r>
             <a:r>
-              <a:rPr sz="1700" b="1">
-                <a:solidFill>
-                  <a:srgbClr val="003399"/>
-                </a:solidFill>
-              </a:rPr>
-              <a:t>Mise en page pro — </a:t>
-            </a:r>
-            <a:r>
-              <a:rPr sz="1700">
+              <a:rPr sz="1600">
                 <a:solidFill>
                   <a:srgbClr val="1A1A2E"/>
                 </a:solidFill>
               </a:rPr>
-              <a:t>page de couverture brandée, table des matières automatique avec vrais numéros de page, en-têtes courants et signets PDF.</a:t>
+              <a:t>couverture, table des matières (vrais n° de page), signets.</a:t>
             </a:r>
           </a:p>
           <a:p>
             <a:pPr>
               <a:lnSpc>
-                <a:spcPct val="105000"/>
+                <a:spcPct val="104000"/>
               </a:lnSpc>
               <a:spcAft>
-                <a:spcPts val="1000"/>
+                <a:spcPts val="900"/>
               </a:spcAft>
             </a:pPr>
             <a:r>
-              <a:rPr sz="1700" b="1">
+              <a:rPr sz="1600" b="1">
                 <a:solidFill>
                   <a:srgbClr val="FFCC00"/>
                 </a:solidFill>
@@ -6618,101 +6350,83 @@
               <a:t>•  </a:t>
             </a:r>
             <a:r>
-              <a:rPr sz="1700" b="1">
+              <a:rPr sz="1600" b="1">
                 <a:solidFill>
                   <a:srgbClr val="003399"/>
                 </a:solidFill>
               </a:rPr>
-              <a:t>Conteneurisé — </a:t>
-            </a:r>
-            <a:r>
-              <a:rPr sz="1700">
+              <a:t>Personnalisable — </a:t>
+            </a:r>
+            <a:r>
+              <a:rPr sz="1600">
                 <a:solidFill>
                   <a:srgbClr val="1A1A2E"/>
                 </a:solidFill>
               </a:rPr>
-              <a:t>image Docker dédiée (docker/weasyprint), profil compose pdf, styles via report.css.</a:t>
+              <a:t>titre, sous-titre, baseUrl, pages à exclure.</a:t>
             </a:r>
           </a:p>
           <a:p>
             <a:pPr>
               <a:lnSpc>
-                <a:spcPct val="105000"/>
+                <a:spcPct val="104000"/>
               </a:lnSpc>
               <a:spcAft>
-                <a:spcPts val="1000"/>
+                <a:spcPts val="900"/>
               </a:spcAft>
             </a:pPr>
             <a:r>
-              <a:rPr sz="1700" b="1">
-                <a:solidFill>
-                  <a:srgbClr val="FFCC00"/>
-                </a:solidFill>
-              </a:rPr>
-              <a:t>•  </a:t>
-            </a:r>
-            <a:r>
-              <a:rPr sz="1700" b="1">
-                <a:solidFill>
-                  <a:srgbClr val="003399"/>
-                </a:solidFill>
-              </a:rPr>
-              <a:t>Options CLI — </a:t>
-            </a:r>
-            <a:r>
-              <a:rPr sz="1700">
-                <a:solidFill>
-                  <a:srgbClr val="1A1A2E"/>
-                </a:solidFill>
-              </a:rPr>
-              <a:t>--base-url, --title / --subtitle / --eyebrow, --exclude (ex. la page LikeC4 interactive non rendue en PDF).</a:t>
-            </a:r>
-          </a:p>
-          <a:p>
-            <a:pPr>
-              <a:lnSpc>
-                <a:spcPct val="105000"/>
-              </a:lnSpc>
-              <a:spcAft>
-                <a:spcPts val="1000"/>
-              </a:spcAft>
-            </a:pPr>
-            <a:r>
-              <a:rPr sz="1700" b="1">
-                <a:solidFill>
-                  <a:srgbClr val="FFCC00"/>
-                </a:solidFill>
-              </a:rPr>
-              <a:t>•  </a:t>
-            </a:r>
-            <a:r>
-              <a:rPr sz="1700" b="1">
-                <a:solidFill>
-                  <a:srgbClr val="003399"/>
-                </a:solidFill>
-              </a:rPr>
-              <a:t>Polices — </a:t>
-            </a:r>
-            <a:r>
-              <a:rPr sz="1700">
-                <a:solidFill>
-                  <a:srgbClr val="1A1A2E"/>
-                </a:solidFill>
-              </a:rPr>
-              <a:t>IBM Plex (Sans / Mono) vendues dans le repo pour un rendu reproductible.</a:t>
-            </a:r>
-          </a:p>
-        </p:txBody>
-      </p:sp>
-      <p:sp>
-        <p:nvSpPr>
-          <p:cNvPr id="7" name="TextBox 6"/>
+              <a:rPr sz="1400" b="1">
+                <a:solidFill>
+                  <a:srgbClr val="1B4FA0"/>
+                </a:solidFill>
+              </a:rPr>
+              <a:t>   –  </a:t>
+            </a:r>
+            <a:r>
+              <a:rPr sz="1400">
+                <a:solidFill>
+                  <a:srgbClr val="4A4A4A"/>
+                </a:solidFill>
+              </a:rPr>
+              <a:t>ex. exclure la page LikeC4 interactive (non imprimable).</a:t>
+            </a:r>
+          </a:p>
+        </p:txBody>
+      </p:sp>
+      <p:pic>
+        <p:nvPicPr>
+          <p:cNvPr id="7" name="Picture 6" descr="03-pdf-usage.png"/>
+          <p:cNvPicPr>
+            <a:picLocks noChangeAspect="1"/>
+          </p:cNvPicPr>
+          <p:nvPr/>
+        </p:nvPicPr>
+        <p:blipFill>
+          <a:blip r:embed="rId2"/>
+          <a:stretch>
+            <a:fillRect/>
+          </a:stretch>
+        </p:blipFill>
+        <p:spPr>
+          <a:xfrm>
+            <a:off x="5806440" y="2320790"/>
+            <a:ext cx="6035040" cy="3130819"/>
+          </a:xfrm>
+          <a:prstGeom prst="rect">
+            <a:avLst/>
+          </a:prstGeom>
+        </p:spPr>
+      </p:pic>
+      <p:sp>
+        <p:nvSpPr>
+          <p:cNvPr id="8" name="TextBox 7"/>
           <p:cNvSpPr txBox="1"/>
           <p:nvPr/>
         </p:nvSpPr>
         <p:spPr>
           <a:xfrm>
-            <a:off x="640080" y="6400800"/>
+            <a:off x="640080" y="6419088"/>
             <a:ext cx="9144000" cy="320040"/>
           </a:xfrm>
           <a:prstGeom prst="rect">
@@ -6726,35 +6440,28 @@
           </a:bodyPr>
           <a:lstStyle/>
           <a:p>
-            <a:pPr algn="l">
-              <a:lnSpc>
-                <a:spcPct val="100000"/>
-              </a:lnSpc>
-              <a:spcAft>
-                <a:spcPts val="600"/>
-              </a:spcAft>
-            </a:pPr>
-            <a:r>
-              <a:rPr sz="900" b="0" i="0">
+            <a:pPr algn="l"/>
+            <a:r>
+              <a:rPr sz="900" b="0">
                 <a:solidFill>
                   <a:srgbClr val="4A4A4A"/>
                 </a:solidFill>
                 <a:latin typeface="Calibri"/>
               </a:rPr>
-              <a:t>Plateforme de documentation Docusaurus — features implémentées</a:t>
-            </a:r>
-          </a:p>
-        </p:txBody>
-      </p:sp>
-      <p:sp>
-        <p:nvSpPr>
-          <p:cNvPr id="8" name="TextBox 7"/>
+              <a:t>Docusaurus — guide d'utilisation</a:t>
+            </a:r>
+          </a:p>
+        </p:txBody>
+      </p:sp>
+      <p:sp>
+        <p:nvSpPr>
+          <p:cNvPr id="9" name="TextBox 8"/>
           <p:cNvSpPr txBox="1"/>
           <p:nvPr/>
         </p:nvSpPr>
         <p:spPr>
           <a:xfrm>
-            <a:off x="11247120" y="6400800"/>
+            <a:off x="11247120" y="6419088"/>
             <a:ext cx="731520" cy="320040"/>
           </a:xfrm>
           <a:prstGeom prst="rect">
@@ -6768,16 +6475,9 @@
           </a:bodyPr>
           <a:lstStyle/>
           <a:p>
-            <a:pPr algn="r">
-              <a:lnSpc>
-                <a:spcPct val="100000"/>
-              </a:lnSpc>
-              <a:spcAft>
-                <a:spcPts val="600"/>
-              </a:spcAft>
-            </a:pPr>
-            <a:r>
-              <a:rPr sz="900" b="1" i="0">
+            <a:pPr algn="r"/>
+            <a:r>
+              <a:rPr sz="900" b="1">
                 <a:solidFill>
                   <a:srgbClr val="4A4A4A"/>
                 </a:solidFill>
@@ -6872,22 +6572,15 @@
           </a:bodyPr>
           <a:lstStyle/>
           <a:p>
-            <a:pPr algn="l">
-              <a:lnSpc>
-                <a:spcPct val="100000"/>
-              </a:lnSpc>
-              <a:spcAft>
-                <a:spcPts val="600"/>
-              </a:spcAft>
-            </a:pPr>
-            <a:r>
-              <a:rPr sz="1300" b="1" i="0">
+            <a:pPr algn="l"/>
+            <a:r>
+              <a:rPr sz="1300" b="1">
                 <a:solidFill>
                   <a:srgbClr val="1B4FA0"/>
                 </a:solidFill>
                 <a:latin typeface="Calibri"/>
               </a:rPr>
-              <a:t>FEATURE 5 (SUITE) — SÉCURITÉ / SUPPLY CHAIN</a:t>
+              <a:t>AUTOMATISER — CI/CD</a:t>
             </a:r>
           </a:p>
         </p:txBody>
@@ -6914,22 +6607,15 @@
           </a:bodyPr>
           <a:lstStyle/>
           <a:p>
-            <a:pPr algn="l">
-              <a:lnSpc>
-                <a:spcPct val="100000"/>
-              </a:lnSpc>
-              <a:spcAft>
-                <a:spcPts val="600"/>
-              </a:spcAft>
-            </a:pPr>
-            <a:r>
-              <a:rPr sz="3000" b="1" i="0">
+            <a:pPr algn="l"/>
+            <a:r>
+              <a:rPr sz="2800" b="1">
                 <a:solidFill>
                   <a:srgbClr val="003399"/>
                 </a:solidFill>
                 <a:latin typeface="Calibri"/>
               </a:rPr>
-              <a:t>Image durcie &amp; build multi-stage</a:t>
+              <a:t>Ce qui se passe à chaque push</a:t>
             </a:r>
           </a:p>
         </p:txBody>
@@ -6942,7 +6628,7 @@
         </p:nvSpPr>
         <p:spPr>
           <a:xfrm>
-            <a:off x="658368" y="1554480"/>
+            <a:off x="658368" y="1481328"/>
             <a:ext cx="2011680" cy="38100"/>
           </a:xfrm>
           <a:prstGeom prst="rect">
@@ -6986,8 +6672,8 @@
         </p:nvSpPr>
         <p:spPr>
           <a:xfrm>
-            <a:off x="658368" y="1920240"/>
-            <a:ext cx="10881360" cy="4297680"/>
+            <a:off x="658368" y="1828800"/>
+            <a:ext cx="10881360" cy="4389120"/>
           </a:xfrm>
           <a:prstGeom prst="rect">
             <a:avLst/>
@@ -7002,14 +6688,14 @@
           <a:p>
             <a:pPr>
               <a:lnSpc>
-                <a:spcPct val="105000"/>
+                <a:spcPct val="104000"/>
               </a:lnSpc>
               <a:spcAft>
-                <a:spcPts val="1000"/>
+                <a:spcPts val="900"/>
               </a:spcAft>
             </a:pPr>
             <a:r>
-              <a:rPr sz="1700" b="1">
+              <a:rPr sz="1600" b="1">
                 <a:solidFill>
                   <a:srgbClr val="FFCC00"/>
                 </a:solidFill>
@@ -7017,33 +6703,33 @@
               <a:t>•  </a:t>
             </a:r>
             <a:r>
-              <a:rPr sz="1700" b="1">
+              <a:rPr sz="1600" b="1">
                 <a:solidFill>
                   <a:srgbClr val="003399"/>
                 </a:solidFill>
               </a:rPr>
-              <a:t>Base hardened — </a:t>
-            </a:r>
-            <a:r>
-              <a:rPr sz="1700">
+              <a:t>Site publié — </a:t>
+            </a:r>
+            <a:r>
+              <a:rPr sz="1600">
                 <a:solidFill>
                   <a:srgbClr val="1A1A2E"/>
                 </a:solidFill>
               </a:rPr>
-              <a:t>image construite sur Red Hat hardened images (hi/python).</a:t>
+              <a:t>le site + documentation.pdf sont déployés sur GitHub Pages.</a:t>
             </a:r>
           </a:p>
           <a:p>
             <a:pPr>
               <a:lnSpc>
-                <a:spcPct val="105000"/>
+                <a:spcPct val="104000"/>
               </a:lnSpc>
               <a:spcAft>
-                <a:spcPts val="1000"/>
+                <a:spcPts val="900"/>
               </a:spcAft>
             </a:pPr>
             <a:r>
-              <a:rPr sz="1700" b="1">
+              <a:rPr sz="1600" b="1">
                 <a:solidFill>
                   <a:srgbClr val="FFCC00"/>
                 </a:solidFill>
@@ -7051,59 +6737,67 @@
               <a:t>•  </a:t>
             </a:r>
             <a:r>
-              <a:rPr sz="1700" b="1">
+              <a:rPr sz="1600" b="1">
                 <a:solidFill>
                   <a:srgbClr val="003399"/>
                 </a:solidFill>
               </a:rPr>
-              <a:t>Multi-stage — </a:t>
-            </a:r>
-            <a:r>
-              <a:rPr sz="1700">
+              <a:t>PDF en artefact — </a:t>
+            </a:r>
+            <a:r>
+              <a:rPr sz="1600">
                 <a:solidFill>
                   <a:srgbClr val="1A1A2E"/>
                 </a:solidFill>
               </a:rPr>
-              <a:t>stage builder (3.12-builder) compile le venv et stage les libs natives + polices ; copiées dans un runtime minimal (3.12).</a:t>
+              <a:t>à chaque push / pull request, le PDF est produit et téléchargeable.</a:t>
             </a:r>
           </a:p>
           <a:p>
             <a:pPr>
               <a:lnSpc>
-                <a:spcPct val="105000"/>
+                <a:spcPct val="104000"/>
               </a:lnSpc>
               <a:spcAft>
-                <a:spcPts val="1000"/>
+                <a:spcPts val="900"/>
               </a:spcAft>
             </a:pPr>
             <a:r>
-              <a:rPr sz="1500" b="1">
-                <a:solidFill>
-                  <a:srgbClr val="1B4FA0"/>
-                </a:solidFill>
-              </a:rPr>
-              <a:t>    –  </a:t>
-            </a:r>
-            <a:r>
-              <a:rPr sz="1500">
-                <a:solidFill>
-                  <a:srgbClr val="4A4A4A"/>
-                </a:solidFill>
-              </a:rPr>
-              <a:t>glibc/éditeur de liens runtime conservés, libs UBI inutiles retirées → image légère.</a:t>
+              <a:rPr sz="1600" b="1">
+                <a:solidFill>
+                  <a:srgbClr val="FFCC00"/>
+                </a:solidFill>
+              </a:rPr>
+              <a:t>•  </a:t>
+            </a:r>
+            <a:r>
+              <a:rPr sz="1600" b="1">
+                <a:solidFill>
+                  <a:srgbClr val="003399"/>
+                </a:solidFill>
+              </a:rPr>
+              <a:t>PDF de release — </a:t>
+            </a:r>
+            <a:r>
+              <a:rPr sz="1600">
+                <a:solidFill>
+                  <a:srgbClr val="1A1A2E"/>
+                </a:solidFill>
+              </a:rPr>
+              <a:t>à chaque release, le PDF d'architecture est proposé en Pull Request.</a:t>
             </a:r>
           </a:p>
           <a:p>
             <a:pPr>
               <a:lnSpc>
-                <a:spcPct val="105000"/>
+                <a:spcPct val="104000"/>
               </a:lnSpc>
               <a:spcAft>
-                <a:spcPts val="1000"/>
+                <a:spcPts val="900"/>
               </a:spcAft>
             </a:pPr>
             <a:r>
-              <a:rPr sz="1700" b="1">
+              <a:rPr sz="1600" b="1">
                 <a:solidFill>
                   <a:srgbClr val="FFCC00"/>
                 </a:solidFill>
@@ -7111,20 +6805,20 @@
               <a:t>•  </a:t>
             </a:r>
             <a:r>
-              <a:rPr sz="1700" b="1">
+              <a:rPr sz="1600" b="1">
                 <a:solidFill>
                   <a:srgbClr val="003399"/>
                 </a:solidFill>
               </a:rPr>
-              <a:t>Dépendances à jour — </a:t>
-            </a:r>
-            <a:r>
-              <a:rPr sz="1700">
+              <a:t>Rien à faire manuellement — </a:t>
+            </a:r>
+            <a:r>
+              <a:rPr sz="1600">
                 <a:solidFill>
                   <a:srgbClr val="1A1A2E"/>
                 </a:solidFill>
               </a:rPr>
-              <a:t>Docusaurus 3.10.1 + likec4 1.58 pour corriger des advisories de sécurité.</a:t>
+              <a:t>vous poussez, la chaîne s'occupe du reste.</a:t>
             </a:r>
           </a:p>
         </p:txBody>
@@ -7137,7 +6831,7 @@
         </p:nvSpPr>
         <p:spPr>
           <a:xfrm>
-            <a:off x="640080" y="6400800"/>
+            <a:off x="640080" y="6419088"/>
             <a:ext cx="9144000" cy="320040"/>
           </a:xfrm>
           <a:prstGeom prst="rect">
@@ -7151,22 +6845,15 @@
           </a:bodyPr>
           <a:lstStyle/>
           <a:p>
-            <a:pPr algn="l">
-              <a:lnSpc>
-                <a:spcPct val="100000"/>
-              </a:lnSpc>
-              <a:spcAft>
-                <a:spcPts val="600"/>
-              </a:spcAft>
-            </a:pPr>
-            <a:r>
-              <a:rPr sz="900" b="0" i="0">
+            <a:pPr algn="l"/>
+            <a:r>
+              <a:rPr sz="900" b="0">
                 <a:solidFill>
                   <a:srgbClr val="4A4A4A"/>
                 </a:solidFill>
                 <a:latin typeface="Calibri"/>
               </a:rPr>
-              <a:t>Plateforme de documentation Docusaurus — features implémentées</a:t>
+              <a:t>Docusaurus — guide d'utilisation</a:t>
             </a:r>
           </a:p>
         </p:txBody>
@@ -7179,7 +6866,7 @@
         </p:nvSpPr>
         <p:spPr>
           <a:xfrm>
-            <a:off x="11247120" y="6400800"/>
+            <a:off x="11247120" y="6419088"/>
             <a:ext cx="731520" cy="320040"/>
           </a:xfrm>
           <a:prstGeom prst="rect">
@@ -7193,16 +6880,9 @@
           </a:bodyPr>
           <a:lstStyle/>
           <a:p>
-            <a:pPr algn="r">
-              <a:lnSpc>
-                <a:spcPct val="100000"/>
-              </a:lnSpc>
-              <a:spcAft>
-                <a:spcPts val="600"/>
-              </a:spcAft>
-            </a:pPr>
-            <a:r>
-              <a:rPr sz="900" b="1" i="0">
+            <a:pPr algn="r"/>
+            <a:r>
+              <a:rPr sz="900" b="1">
                 <a:solidFill>
                   <a:srgbClr val="4A4A4A"/>
                 </a:solidFill>
@@ -7297,22 +6977,15 @@
           </a:bodyPr>
           <a:lstStyle/>
           <a:p>
-            <a:pPr algn="l">
-              <a:lnSpc>
-                <a:spcPct val="100000"/>
-              </a:lnSpc>
-              <a:spcAft>
-                <a:spcPts val="600"/>
-              </a:spcAft>
-            </a:pPr>
-            <a:r>
-              <a:rPr sz="1300" b="1" i="0">
+            <a:pPr algn="l"/>
+            <a:r>
+              <a:rPr sz="1300" b="1">
                 <a:solidFill>
                   <a:srgbClr val="1B4FA0"/>
                 </a:solidFill>
                 <a:latin typeface="Calibri"/>
               </a:rPr>
-              <a:t>FEATURE 6 — BUILD &amp; DÉPLOIEMENT</a:t>
+              <a:t>AIDE-MÉMOIRE — COMMANDES</a:t>
             </a:r>
           </a:p>
         </p:txBody>
@@ -7339,22 +7012,15 @@
           </a:bodyPr>
           <a:lstStyle/>
           <a:p>
-            <a:pPr algn="l">
-              <a:lnSpc>
-                <a:spcPct val="100000"/>
-              </a:lnSpc>
-              <a:spcAft>
-                <a:spcPts val="600"/>
-              </a:spcAft>
-            </a:pPr>
-            <a:r>
-              <a:rPr sz="3000" b="1" i="0">
+            <a:pPr algn="l"/>
+            <a:r>
+              <a:rPr sz="2800" b="1">
                 <a:solidFill>
                   <a:srgbClr val="003399"/>
                 </a:solidFill>
                 <a:latin typeface="Calibri"/>
               </a:rPr>
-              <a:t>Industrialisation : CI/CD &amp; Docker</a:t>
+              <a:t>Les commandes essentielles</a:t>
             </a:r>
           </a:p>
         </p:txBody>
@@ -7367,7 +7033,7 @@
         </p:nvSpPr>
         <p:spPr>
           <a:xfrm>
-            <a:off x="658368" y="1554480"/>
+            <a:off x="658368" y="1481328"/>
             <a:ext cx="2011680" cy="38100"/>
           </a:xfrm>
           <a:prstGeom prst="rect">
@@ -7411,8 +7077,8 @@
         </p:nvSpPr>
         <p:spPr>
           <a:xfrm>
-            <a:off x="658368" y="1920240"/>
-            <a:ext cx="10881360" cy="4297680"/>
+            <a:off x="658368" y="1828800"/>
+            <a:ext cx="5029200" cy="4389120"/>
           </a:xfrm>
           <a:prstGeom prst="rect">
             <a:avLst/>
@@ -7427,14 +7093,14 @@
           <a:p>
             <a:pPr>
               <a:lnSpc>
-                <a:spcPct val="105000"/>
+                <a:spcPct val="104000"/>
               </a:lnSpc>
               <a:spcAft>
-                <a:spcPts val="1000"/>
+                <a:spcPts val="900"/>
               </a:spcAft>
             </a:pPr>
             <a:r>
-              <a:rPr sz="1700" b="1">
+              <a:rPr sz="1600" b="1">
                 <a:solidFill>
                   <a:srgbClr val="FFCC00"/>
                 </a:solidFill>
@@ -7442,59 +7108,67 @@
               <a:t>•  </a:t>
             </a:r>
             <a:r>
-              <a:rPr sz="1700" b="1">
+              <a:rPr sz="1600" b="1">
                 <a:solidFill>
                   <a:srgbClr val="003399"/>
                 </a:solidFill>
               </a:rPr>
-              <a:t>deploy.yml — </a:t>
-            </a:r>
-            <a:r>
-              <a:rPr sz="1700">
+              <a:t>make dev — </a:t>
+            </a:r>
+            <a:r>
+              <a:rPr sz="1600">
                 <a:solidFill>
                   <a:srgbClr val="1A1A2E"/>
                 </a:solidFill>
               </a:rPr>
-              <a:t>publie le site + documentation.pdf sur GitHub Pages (téléchargeable depuis l'URL déployée).</a:t>
+              <a:t>serveur local + aperçu en direct.</a:t>
             </a:r>
           </a:p>
           <a:p>
             <a:pPr>
               <a:lnSpc>
-                <a:spcPct val="105000"/>
+                <a:spcPct val="104000"/>
               </a:lnSpc>
               <a:spcAft>
-                <a:spcPts val="1000"/>
+                <a:spcPts val="900"/>
               </a:spcAft>
             </a:pPr>
             <a:r>
-              <a:rPr sz="1500" b="1">
-                <a:solidFill>
-                  <a:srgbClr val="1B4FA0"/>
-                </a:solidFill>
-              </a:rPr>
-              <a:t>    –  </a:t>
-            </a:r>
-            <a:r>
-              <a:rPr sz="1500">
-                <a:solidFill>
-                  <a:srgbClr val="4A4A4A"/>
-                </a:solidFill>
-              </a:rPr>
-              <a:t>à chaque push et pull request : artefact documentation-pdf produit (job build-pdf).</a:t>
+              <a:rPr sz="1600" b="1">
+                <a:solidFill>
+                  <a:srgbClr val="FFCC00"/>
+                </a:solidFill>
+              </a:rPr>
+              <a:t>•  </a:t>
+            </a:r>
+            <a:r>
+              <a:rPr sz="1600" b="1">
+                <a:solidFill>
+                  <a:srgbClr val="003399"/>
+                </a:solidFill>
+              </a:rPr>
+              <a:t>make prod — </a:t>
+            </a:r>
+            <a:r>
+              <a:rPr sz="1600">
+                <a:solidFill>
+                  <a:srgbClr val="1A1A2E"/>
+                </a:solidFill>
+              </a:rPr>
+              <a:t>build de production (Caddy).</a:t>
             </a:r>
           </a:p>
           <a:p>
             <a:pPr>
               <a:lnSpc>
-                <a:spcPct val="105000"/>
+                <a:spcPct val="104000"/>
               </a:lnSpc>
               <a:spcAft>
-                <a:spcPts val="1000"/>
+                <a:spcPts val="900"/>
               </a:spcAft>
             </a:pPr>
             <a:r>
-              <a:rPr sz="1700" b="1">
+              <a:rPr sz="1600" b="1">
                 <a:solidFill>
                   <a:srgbClr val="FFCC00"/>
                 </a:solidFill>
@@ -7502,33 +7176,33 @@
               <a:t>•  </a:t>
             </a:r>
             <a:r>
-              <a:rPr sz="1700" b="1">
+              <a:rPr sz="1600" b="1">
                 <a:solidFill>
                   <a:srgbClr val="003399"/>
                 </a:solidFill>
               </a:rPr>
-              <a:t>architecture-pdf-release.yml — </a:t>
-            </a:r>
-            <a:r>
-              <a:rPr sz="1700">
+              <a:t>make pdf — </a:t>
+            </a:r>
+            <a:r>
+              <a:rPr sz="1600">
                 <a:solidFill>
                   <a:srgbClr val="1A1A2E"/>
                 </a:solidFill>
               </a:rPr>
-              <a:t>propose le PDF d'architecture en Pull Request à chaque release (ouverte via un PAT).</a:t>
+              <a:t>exporter la doc en PDF.</a:t>
             </a:r>
           </a:p>
           <a:p>
             <a:pPr>
               <a:lnSpc>
-                <a:spcPct val="105000"/>
+                <a:spcPct val="104000"/>
               </a:lnSpc>
               <a:spcAft>
-                <a:spcPts val="1000"/>
+                <a:spcPts val="900"/>
               </a:spcAft>
             </a:pPr>
             <a:r>
-              <a:rPr sz="1700" b="1">
+              <a:rPr sz="1600" b="1">
                 <a:solidFill>
                   <a:srgbClr val="FFCC00"/>
                 </a:solidFill>
@@ -7536,67 +7210,57 @@
               <a:t>•  </a:t>
             </a:r>
             <a:r>
-              <a:rPr sz="1700" b="1">
+              <a:rPr sz="1600" b="1">
                 <a:solidFill>
                   <a:srgbClr val="003399"/>
                 </a:solidFill>
               </a:rPr>
-              <a:t>Docker / compose — </a:t>
-            </a:r>
-            <a:r>
-              <a:rPr sz="1700">
+              <a:t>Un seul point d'entrée — </a:t>
+            </a:r>
+            <a:r>
+              <a:rPr sz="1600">
                 <a:solidFill>
                   <a:srgbClr val="1A1A2E"/>
                 </a:solidFill>
               </a:rPr>
-              <a:t>compose.yaml (dev + profil pdf), compose-prod.yaml, reverse-proxy Caddy.</a:t>
-            </a:r>
-          </a:p>
-          <a:p>
-            <a:pPr>
-              <a:lnSpc>
-                <a:spcPct val="105000"/>
-              </a:lnSpc>
-              <a:spcAft>
-                <a:spcPts val="1000"/>
-              </a:spcAft>
-            </a:pPr>
-            <a:r>
-              <a:rPr sz="1700" b="1">
-                <a:solidFill>
-                  <a:srgbClr val="FFCC00"/>
-                </a:solidFill>
-              </a:rPr>
-              <a:t>•  </a:t>
-            </a:r>
-            <a:r>
-              <a:rPr sz="1700" b="1">
-                <a:solidFill>
-                  <a:srgbClr val="003399"/>
-                </a:solidFill>
-              </a:rPr>
-              <a:t>Makefile — </a:t>
-            </a:r>
-            <a:r>
-              <a:rPr sz="1700">
-                <a:solidFill>
-                  <a:srgbClr val="1A1A2E"/>
-                </a:solidFill>
-              </a:rPr>
-              <a:t>make dev, make prod, make pdf — un point d'entrée unique pour toute la chaîne.</a:t>
-            </a:r>
-          </a:p>
-        </p:txBody>
-      </p:sp>
-      <p:sp>
-        <p:nvSpPr>
-          <p:cNvPr id="7" name="TextBox 6"/>
+              <a:t>le Makefile orchestre toute la chaîne.</a:t>
+            </a:r>
+          </a:p>
+        </p:txBody>
+      </p:sp>
+      <p:pic>
+        <p:nvPicPr>
+          <p:cNvPr id="7" name="Picture 6" descr="02-make-commands.png"/>
+          <p:cNvPicPr>
+            <a:picLocks noChangeAspect="1"/>
+          </p:cNvPicPr>
+          <p:nvPr/>
+        </p:nvPicPr>
+        <p:blipFill>
+          <a:blip r:embed="rId2"/>
+          <a:stretch>
+            <a:fillRect/>
+          </a:stretch>
+        </p:blipFill>
+        <p:spPr>
+          <a:xfrm>
+            <a:off x="5806440" y="2239593"/>
+            <a:ext cx="6035040" cy="3293213"/>
+          </a:xfrm>
+          <a:prstGeom prst="rect">
+            <a:avLst/>
+          </a:prstGeom>
+        </p:spPr>
+      </p:pic>
+      <p:sp>
+        <p:nvSpPr>
+          <p:cNvPr id="8" name="TextBox 7"/>
           <p:cNvSpPr txBox="1"/>
           <p:nvPr/>
         </p:nvSpPr>
         <p:spPr>
           <a:xfrm>
-            <a:off x="640080" y="6400800"/>
+            <a:off x="640080" y="6419088"/>
             <a:ext cx="9144000" cy="320040"/>
           </a:xfrm>
           <a:prstGeom prst="rect">
@@ -7610,35 +7274,28 @@
           </a:bodyPr>
           <a:lstStyle/>
           <a:p>
-            <a:pPr algn="l">
-              <a:lnSpc>
-                <a:spcPct val="100000"/>
-              </a:lnSpc>
-              <a:spcAft>
-                <a:spcPts val="600"/>
-              </a:spcAft>
-            </a:pPr>
-            <a:r>
-              <a:rPr sz="900" b="0" i="0">
+            <a:pPr algn="l"/>
+            <a:r>
+              <a:rPr sz="900" b="0">
                 <a:solidFill>
                   <a:srgbClr val="4A4A4A"/>
                 </a:solidFill>
                 <a:latin typeface="Calibri"/>
               </a:rPr>
-              <a:t>Plateforme de documentation Docusaurus — features implémentées</a:t>
-            </a:r>
-          </a:p>
-        </p:txBody>
-      </p:sp>
-      <p:sp>
-        <p:nvSpPr>
-          <p:cNvPr id="8" name="TextBox 7"/>
+              <a:t>Docusaurus — guide d'utilisation</a:t>
+            </a:r>
+          </a:p>
+        </p:txBody>
+      </p:sp>
+      <p:sp>
+        <p:nvSpPr>
+          <p:cNvPr id="9" name="TextBox 8"/>
           <p:cNvSpPr txBox="1"/>
           <p:nvPr/>
         </p:nvSpPr>
         <p:spPr>
           <a:xfrm>
-            <a:off x="11247120" y="6400800"/>
+            <a:off x="11247120" y="6419088"/>
             <a:ext cx="731520" cy="320040"/>
           </a:xfrm>
           <a:prstGeom prst="rect">
@@ -7652,16 +7309,9 @@
           </a:bodyPr>
           <a:lstStyle/>
           <a:p>
-            <a:pPr algn="r">
-              <a:lnSpc>
-                <a:spcPct val="100000"/>
-              </a:lnSpc>
-              <a:spcAft>
-                <a:spcPts val="600"/>
-              </a:spcAft>
-            </a:pPr>
-            <a:r>
-              <a:rPr sz="900" b="1" i="0">
+            <a:pPr algn="r"/>
+            <a:r>
+              <a:rPr sz="900" b="1">
                 <a:solidFill>
                   <a:srgbClr val="4A4A4A"/>
                 </a:solidFill>

</xml_diff>